<commit_message>
Replace presentation with updated version
</commit_message>
<xml_diff>
--- a/presentation/Prompting_Comparison_BIT_Mesra.pptx
+++ b/presentation/Prompting_Comparison_BIT_Mesra.pptx
@@ -4,6 +4,9 @@
   <p:sldMasterIdLst>
     <p:sldMasterId id="2147483648" r:id="rId1"/>
   </p:sldMasterIdLst>
+  <p:notesMasterIdLst>
+    <p:notesMasterId r:id="rId12"/>
+  </p:notesMasterIdLst>
   <p:sldIdLst>
     <p:sldId id="256" r:id="rId2"/>
     <p:sldId id="257" r:id="rId3"/>
@@ -16,10 +19,7 @@
     <p:sldId id="264" r:id="rId10"/>
     <p:sldId id="265" r:id="rId11"/>
   </p:sldIdLst>
-  <p:notesMasterIdLst>
-    <p:notesMasterId r:id="rId12"/>
-  </p:notesMasterIdLst>
-  <p:sldSz cx="9144000" cy="5143500"/>
+  <p:sldSz cx="9144000" cy="5143500" type="screen16x9"/>
   <p:notesSz cx="5143500" cy="9144000"/>
   <p:defaultTextStyle>
     <a:lvl1pPr marL="0" algn="l" defTabSz="914400" rtl="0" eaLnBrk="1" latinLnBrk="0" hangingPunct="1">
@@ -116,27 +116,27 @@
   <p:extLst>
     <p:ext uri="{521415D9-36F7-43E2-AB2F-B90AF26B5E84}">
       <p14:sectionLst xmlns:p14="http://schemas.microsoft.com/office/powerpoint/2010/main">
-        <p14:section name="Introduction" id="{28ac3f19-9265-3446-d247-74540a0bb49b}">
+        <p14:section name="Introduction" id="{28AC3F19-9265-3446-D247-74540A0BB49B}">
           <p14:sldIdLst>
             <p14:sldId id="256"/>
             <p14:sldId id="257"/>
             <p14:sldId id="258"/>
           </p14:sldIdLst>
         </p14:section>
-        <p14:section name="Method" id="{fad722f3-c753-ba31-4f5d-450d90a80968}">
+        <p14:section name="Method" id="{FAD722F3-C753-BA31-4F5D-450D90A80968}">
           <p14:sldIdLst>
             <p14:sldId id="259"/>
             <p14:sldId id="260"/>
             <p14:sldId id="261"/>
           </p14:sldIdLst>
         </p14:section>
-        <p14:section name="Results" id="{5807ea68-7d5e-63c6-358c-4d86878e154a}">
+        <p14:section name="Results" id="{5807EA68-7D5E-63C6-358C-4D86878E154A}">
           <p14:sldIdLst>
             <p14:sldId id="262"/>
             <p14:sldId id="263"/>
           </p14:sldIdLst>
         </p14:section>
-        <p14:section name="Wrap-up" id="{c38a5d03-3736-c593-deab-e1e833b7c1c0}">
+        <p14:section name="Wrap-up" id="{C38A5D03-3736-C593-DEAB-E1E833B7C1C0}">
           <p14:sldIdLst>
             <p14:sldId id="264"/>
             <p14:sldId id="265"/>
@@ -152,9 +152,11 @@
 </file>
 
 <file path=ppt/charts/chart1.xml><?xml version="1.0" encoding="utf-8"?>
-<c:chartSpace xmlns:c="http://schemas.openxmlformats.org/drawingml/2006/chart" xmlns:a="http://schemas.openxmlformats.org/drawingml/2006/main" xmlns:r="http://schemas.openxmlformats.org/officeDocument/2006/relationships">
+<c:chartSpace xmlns:c="http://schemas.openxmlformats.org/drawingml/2006/chart" xmlns:a="http://schemas.openxmlformats.org/drawingml/2006/main" xmlns:r="http://schemas.openxmlformats.org/officeDocument/2006/relationships" xmlns:c16r2="http://schemas.microsoft.com/office/drawing/2015/06/chart">
   <c:date1904 val="0"/>
+  <c:lang val="en-US"/>
   <c:roundedCorners val="1"/>
+  <c:style val="2"/>
   <c:chart>
     <c:title>
       <c:tx>
@@ -171,7 +173,7 @@
               </a:defRPr>
             </a:pPr>
             <a:r>
-              <a:rPr sz="1300" b="0" i="0" u="none" strike="noStrike">
+              <a:rPr lang="en-IN" sz="1300" b="0" i="0" u="none" strike="noStrike">
                 <a:solidFill>
                   <a:srgbClr val="12263F"/>
                 </a:solidFill>
@@ -182,7 +184,6 @@
           </a:p>
         </c:rich>
       </c:tx>
-      <c:layout/>
       <c:overlay val="0"/>
     </c:title>
     <c:autoTitleDeleted val="0"/>
@@ -215,18 +216,26 @@
           <c:invertIfNegative val="0"/>
           <c:dLbls>
             <c:numFmt formatCode="#,##0" sourceLinked="0"/>
+            <c:spPr>
+              <a:noFill/>
+              <a:ln>
+                <a:noFill/>
+              </a:ln>
+              <a:effectLst/>
+            </c:spPr>
             <c:txPr>
               <a:bodyPr/>
               <a:lstStyle/>
               <a:p>
                 <a:pPr>
-                  <a:defRPr b="0" i="0" strike="noStrike" sz="1000" u="none">
+                  <a:defRPr sz="1000" b="0" i="0" u="none" strike="noStrike">
                     <a:solidFill>
                       <a:srgbClr val="1F2933"/>
                     </a:solidFill>
                     <a:latin typeface="+mn-lt"/>
                   </a:defRPr>
                 </a:pPr>
+                <a:endParaRPr lang="en-US"/>
               </a:p>
             </c:txPr>
             <c:showLegendKey val="0"/>
@@ -236,28 +245,31 @@
             <c:showPercent val="0"/>
             <c:showBubbleSize val="0"/>
             <c:showLeaderLines val="0"/>
+            <c:extLst>
+              <c:ext xmlns:c15="http://schemas.microsoft.com/office/drawing/2012/chart" uri="{CE6537A1-D6FC-4f65-9D91-7224C49458BB}">
+                <c15:showLeaderLines val="0"/>
+              </c:ext>
+            </c:extLst>
           </c:dLbls>
           <c:cat>
-            <c:multiLvlStrRef>
+            <c:strRef>
               <c:f>Sheet1!$A$2:$A$5</c:f>
-              <c:multiLvlStrCache>
+              <c:strCache>
                 <c:ptCount val="4"/>
-                <c:lvl>
-                  <c:pt idx="0">
-                    <c:v>Math</c:v>
-                  </c:pt>
-                  <c:pt idx="1">
-                    <c:v>Logic</c:v>
-                  </c:pt>
-                  <c:pt idx="2">
-                    <c:v>Aptitude</c:v>
-                  </c:pt>
-                  <c:pt idx="3">
-                    <c:v>Algorithmic</c:v>
-                  </c:pt>
-                </c:lvl>
-              </c:multiLvlStrCache>
-            </c:multiLvlStrRef>
+                <c:pt idx="0">
+                  <c:v>Math</c:v>
+                </c:pt>
+                <c:pt idx="1">
+                  <c:v>Logic</c:v>
+                </c:pt>
+                <c:pt idx="2">
+                  <c:v>Aptitude</c:v>
+                </c:pt>
+                <c:pt idx="3">
+                  <c:v>Algorithmic</c:v>
+                </c:pt>
+              </c:strCache>
+            </c:strRef>
           </c:cat>
           <c:val>
             <c:numRef>
@@ -280,6 +292,11 @@
               </c:numCache>
             </c:numRef>
           </c:val>
+          <c:extLst>
+            <c:ext xmlns:c16="http://schemas.microsoft.com/office/drawing/2014/chart" uri="{C3380CC4-5D6E-409C-BE32-E72D297353CC}">
+              <c16:uniqueId val="{00000000-26A3-415C-AA84-2C639E15932E}"/>
+            </c:ext>
+          </c:extLst>
         </c:ser>
         <c:ser>
           <c:idx val="1"/>
@@ -304,18 +321,26 @@
           <c:invertIfNegative val="0"/>
           <c:dLbls>
             <c:numFmt formatCode="#,##0" sourceLinked="0"/>
+            <c:spPr>
+              <a:noFill/>
+              <a:ln>
+                <a:noFill/>
+              </a:ln>
+              <a:effectLst/>
+            </c:spPr>
             <c:txPr>
               <a:bodyPr/>
               <a:lstStyle/>
               <a:p>
                 <a:pPr>
-                  <a:defRPr b="0" i="0" strike="noStrike" sz="1000" u="none">
+                  <a:defRPr sz="1000" b="0" i="0" u="none" strike="noStrike">
                     <a:solidFill>
                       <a:srgbClr val="1F2933"/>
                     </a:solidFill>
                     <a:latin typeface="+mn-lt"/>
                   </a:defRPr>
                 </a:pPr>
+                <a:endParaRPr lang="en-US"/>
               </a:p>
             </c:txPr>
             <c:showLegendKey val="0"/>
@@ -325,28 +350,31 @@
             <c:showPercent val="0"/>
             <c:showBubbleSize val="0"/>
             <c:showLeaderLines val="0"/>
+            <c:extLst>
+              <c:ext xmlns:c15="http://schemas.microsoft.com/office/drawing/2012/chart" uri="{CE6537A1-D6FC-4f65-9D91-7224C49458BB}">
+                <c15:showLeaderLines val="0"/>
+              </c:ext>
+            </c:extLst>
           </c:dLbls>
           <c:cat>
-            <c:multiLvlStrRef>
+            <c:strRef>
               <c:f>Sheet1!$A$2:$A$5</c:f>
-              <c:multiLvlStrCache>
+              <c:strCache>
                 <c:ptCount val="4"/>
-                <c:lvl>
-                  <c:pt idx="0">
-                    <c:v>Math</c:v>
-                  </c:pt>
-                  <c:pt idx="1">
-                    <c:v>Logic</c:v>
-                  </c:pt>
-                  <c:pt idx="2">
-                    <c:v>Aptitude</c:v>
-                  </c:pt>
-                  <c:pt idx="3">
-                    <c:v>Algorithmic</c:v>
-                  </c:pt>
-                </c:lvl>
-              </c:multiLvlStrCache>
-            </c:multiLvlStrRef>
+                <c:pt idx="0">
+                  <c:v>Math</c:v>
+                </c:pt>
+                <c:pt idx="1">
+                  <c:v>Logic</c:v>
+                </c:pt>
+                <c:pt idx="2">
+                  <c:v>Aptitude</c:v>
+                </c:pt>
+                <c:pt idx="3">
+                  <c:v>Algorithmic</c:v>
+                </c:pt>
+              </c:strCache>
+            </c:strRef>
           </c:cat>
           <c:val>
             <c:numRef>
@@ -369,36 +397,23 @@
               </c:numCache>
             </c:numRef>
           </c:val>
+          <c:extLst>
+            <c:ext xmlns:c16="http://schemas.microsoft.com/office/drawing/2014/chart" uri="{C3380CC4-5D6E-409C-BE32-E72D297353CC}">
+              <c16:uniqueId val="{00000001-26A3-415C-AA84-2C639E15932E}"/>
+            </c:ext>
+          </c:extLst>
         </c:ser>
         <c:dLbls>
-          <c:numFmt formatCode="#,##0" sourceLinked="0"/>
-          <c:txPr>
-            <a:bodyPr/>
-            <a:lstStyle/>
-            <a:p>
-              <a:pPr>
-                <a:defRPr b="0" i="0" strike="noStrike" sz="1000" u="none">
-                  <a:solidFill>
-                    <a:srgbClr val="1F2933"/>
-                  </a:solidFill>
-                  <a:latin typeface="+mn-lt"/>
-                </a:defRPr>
-              </a:pPr>
-            </a:p>
-          </c:txPr>
           <c:showLegendKey val="0"/>
           <c:showVal val="1"/>
           <c:showCatName val="0"/>
           <c:showSerName val="0"/>
           <c:showPercent val="0"/>
           <c:showBubbleSize val="0"/>
-          <c:showLeaderLines val="0"/>
         </c:dLbls>
         <c:gapWidth val="150"/>
-        <c:overlap val="0"/>
         <c:axId val="2094734554"/>
         <c:axId val="2094734552"/>
-        <c:axId val="2094734556"/>
       </c:barChart>
       <c:catAx>
         <c:axId val="2094734554"/>
@@ -439,6 +454,7 @@
         <c:crosses val="autoZero"/>
         <c:auto val="1"/>
         <c:lblAlgn val="ctr"/>
+        <c:lblOffset val="100"/>
         <c:noMultiLvlLbl val="1"/>
       </c:catAx>
       <c:valAx>
@@ -523,6 +539,7 @@
     </c:legend>
     <c:plotVisOnly val="1"/>
     <c:dispBlanksAs val="span"/>
+    <c:showDLblsOverMax val="1"/>
   </c:chart>
   <c:spPr>
     <a:noFill/>
@@ -559,234 +576,10 @@
           <a:chExt cx="0" cy="0"/>
         </a:xfrm>
       </p:grpSpPr>
-      <p:sp>
-        <p:nvSpPr>
-          <p:cNvPr id="2" name="Header Placeholder 1"/>
-          <p:cNvSpPr>
-            <a:spLocks noGrp="1"/>
-          </p:cNvSpPr>
-          <p:nvPr>
-            <p:ph type="hdr" sz="quarter"/>
-          </p:nvPr>
-        </p:nvSpPr>
-        <p:spPr>
-          <a:xfrm>
-            <a:off x="0" y="0"/>
-            <a:ext cx="2971800" cy="458788"/>
-          </a:xfrm>
-          <a:prstGeom prst="rect">
-            <a:avLst/>
-          </a:prstGeom>
-        </p:spPr>
-        <p:txBody>
-          <a:bodyPr vert="horz" lIns="91440" tIns="45720" rIns="91440" bIns="45720" rtlCol="0"/>
-          <a:lstStyle>
-            <a:lvl1pPr algn="l">
-              <a:defRPr sz="1200"/>
-            </a:lvl1pPr>
-          </a:lstStyle>
-          <a:p>
-            <a:endParaRPr lang="en-US"/>
-          </a:p>
-        </p:txBody>
-      </p:sp>
-      <p:sp>
-        <p:nvSpPr>
-          <p:cNvPr id="3" name="Date Placeholder 2"/>
-          <p:cNvSpPr>
-            <a:spLocks noGrp="1"/>
-          </p:cNvSpPr>
-          <p:nvPr>
-            <p:ph type="dt" idx="1"/>
-          </p:nvPr>
-        </p:nvSpPr>
-        <p:spPr>
-          <a:xfrm>
-            <a:off x="3884613" y="0"/>
-            <a:ext cx="2971800" cy="458788"/>
-          </a:xfrm>
-          <a:prstGeom prst="rect">
-            <a:avLst/>
-          </a:prstGeom>
-        </p:spPr>
-        <p:txBody>
-          <a:bodyPr vert="horz" lIns="91440" tIns="45720" rIns="91440" bIns="45720" rtlCol="0"/>
-          <a:lstStyle>
-            <a:lvl1pPr algn="r">
-              <a:defRPr sz="1200"/>
-            </a:lvl1pPr>
-          </a:lstStyle>
-          <a:p>
-            <a:fld id="{5282F153-3F37-0F45-9E97-73ACFA13230C}" type="datetimeFigureOut">
-              <a:rPr lang="en-US"/>
-              <a:t>7/23/19</a:t>
-            </a:fld>
-            <a:endParaRPr lang="en-US"/>
-          </a:p>
-        </p:txBody>
-      </p:sp>
-      <p:sp>
-        <p:nvSpPr>
-          <p:cNvPr id="4" name="Slide Image Placeholder 3"/>
-          <p:cNvSpPr>
-            <a:spLocks noGrp="1" noRot="1" noChangeAspect="1"/>
-          </p:cNvSpPr>
-          <p:nvPr>
-            <p:ph type="sldImg" idx="2"/>
-          </p:nvPr>
-        </p:nvSpPr>
-        <p:spPr>
-          <a:xfrm>
-            <a:off x="685800" y="1143000"/>
-            <a:ext cx="5486400" cy="3086100"/>
-          </a:xfrm>
-          <a:prstGeom prst="rect">
-            <a:avLst/>
-          </a:prstGeom>
-          <a:noFill/>
-          <a:ln w="12700">
-            <a:solidFill>
-              <a:prstClr val="black"/>
-            </a:solidFill>
-          </a:ln>
-        </p:spPr>
-        <p:txBody>
-          <a:bodyPr vert="horz" lIns="91440" tIns="45720" rIns="91440" bIns="45720" rtlCol="0" anchor="ctr"/>
-          <a:lstStyle/>
-          <a:p>
-            <a:endParaRPr lang="en-US"/>
-          </a:p>
-        </p:txBody>
-      </p:sp>
-      <p:sp>
-        <p:nvSpPr>
-          <p:cNvPr id="5" name="Notes Placeholder 4"/>
-          <p:cNvSpPr>
-            <a:spLocks noGrp="1"/>
-          </p:cNvSpPr>
-          <p:nvPr>
-            <p:ph type="body" sz="quarter" idx="3"/>
-          </p:nvPr>
-        </p:nvSpPr>
-        <p:spPr>
-          <a:xfrm>
-            <a:off x="685800" y="4400550"/>
-            <a:ext cx="5486400" cy="3600450"/>
-          </a:xfrm>
-          <a:prstGeom prst="rect">
-            <a:avLst/>
-          </a:prstGeom>
-        </p:spPr>
-        <p:txBody>
-          <a:bodyPr vert="horz" lIns="91440" tIns="45720" rIns="91440" bIns="45720" rtlCol="0"/>
-          <a:lstStyle/>
-          <a:p>
-            <a:pPr lvl="0"/>
-            <a:r>
-              <a:rPr lang="en-US"/>
-              <a:t>Click to edit Master text styles</a:t>
-            </a:r>
-          </a:p>
-          <a:p>
-            <a:pPr lvl="1"/>
-            <a:r>
-              <a:rPr lang="en-US"/>
-              <a:t>Second level</a:t>
-            </a:r>
-          </a:p>
-          <a:p>
-            <a:pPr lvl="2"/>
-            <a:r>
-              <a:rPr lang="en-US"/>
-              <a:t>Third level</a:t>
-            </a:r>
-          </a:p>
-          <a:p>
-            <a:pPr lvl="3"/>
-            <a:r>
-              <a:rPr lang="en-US"/>
-              <a:t>Fourth level</a:t>
-            </a:r>
-          </a:p>
-          <a:p>
-            <a:pPr lvl="4"/>
-            <a:r>
-              <a:rPr lang="en-US"/>
-              <a:t>Fifth level</a:t>
-            </a:r>
-          </a:p>
-        </p:txBody>
-      </p:sp>
-      <p:sp>
-        <p:nvSpPr>
-          <p:cNvPr id="6" name="Footer Placeholder 5"/>
-          <p:cNvSpPr>
-            <a:spLocks noGrp="1"/>
-          </p:cNvSpPr>
-          <p:nvPr>
-            <p:ph type="ftr" sz="quarter" idx="4"/>
-          </p:nvPr>
-        </p:nvSpPr>
-        <p:spPr>
-          <a:xfrm>
-            <a:off x="0" y="8685213"/>
-            <a:ext cx="2971800" cy="458787"/>
-          </a:xfrm>
-          <a:prstGeom prst="rect">
-            <a:avLst/>
-          </a:prstGeom>
-        </p:spPr>
-        <p:txBody>
-          <a:bodyPr vert="horz" lIns="91440" tIns="45720" rIns="91440" bIns="45720" rtlCol="0" anchor="b"/>
-          <a:lstStyle>
-            <a:lvl1pPr algn="l">
-              <a:defRPr sz="1200"/>
-            </a:lvl1pPr>
-          </a:lstStyle>
-          <a:p>
-            <a:endParaRPr lang="en-US"/>
-          </a:p>
-        </p:txBody>
-      </p:sp>
-      <p:sp>
-        <p:nvSpPr>
-          <p:cNvPr id="7" name="Slide Number Placeholder 6"/>
-          <p:cNvSpPr>
-            <a:spLocks noGrp="1"/>
-          </p:cNvSpPr>
-          <p:nvPr>
-            <p:ph type="sldNum" sz="quarter" idx="5"/>
-          </p:nvPr>
-        </p:nvSpPr>
-        <p:spPr>
-          <a:xfrm>
-            <a:off x="3884613" y="8685213"/>
-            <a:ext cx="2971800" cy="458787"/>
-          </a:xfrm>
-          <a:prstGeom prst="rect">
-            <a:avLst/>
-          </a:prstGeom>
-        </p:spPr>
-        <p:txBody>
-          <a:bodyPr vert="horz" lIns="91440" tIns="45720" rIns="91440" bIns="45720" rtlCol="0" anchor="b"/>
-          <a:lstStyle>
-            <a:lvl1pPr algn="r">
-              <a:defRPr sz="1200"/>
-            </a:lvl1pPr>
-          </a:lstStyle>
-          <a:p>
-            <a:fld id="{CE5E9CC1-C706-0F49-92D6-E571CC5EEA8F}" type="slidenum">
-              <a:rPr lang="en-US"/>
-              <a:t>‹#›</a:t>
-            </a:fld>
-            <a:endParaRPr lang="en-US"/>
-          </a:p>
-        </p:txBody>
-      </p:sp>
     </p:spTree>
     <p:extLst>
       <p:ext uri="{BB962C8B-B14F-4D97-AF65-F5344CB8AC3E}">
-        <p14:creationId xmlns:p14="http://schemas.microsoft.com/office/powerpoint/2010/main" val="1024086991"/>
+        <p14:creationId xmlns:p14="http://schemas.microsoft.com/office/powerpoint/2010/main" val="2060396454"/>
       </p:ext>
     </p:extLst>
   </p:cSld>
@@ -934,7 +727,6 @@
               <a:rPr lang="en-US" dirty="0"/>
               <a:t>Introduce the two prompting strategies and the model used (Gemini via the Google Gemini API). Add your name and roll number on this slide.</a:t>
             </a:r>
-            <a:endParaRPr lang="en-US" dirty="0"/>
           </a:p>
         </p:txBody>
       </p:sp>
@@ -1022,7 +814,6 @@
               <a:rPr lang="en-US" dirty="0"/>
               <a:t>Close with thanks and invite questions.</a:t>
             </a:r>
-            <a:endParaRPr lang="en-US" dirty="0"/>
           </a:p>
         </p:txBody>
       </p:sp>
@@ -1110,7 +901,6 @@
               <a:rPr lang="en-US" dirty="0"/>
               <a:t>Frame the practical question: is the extra cost of structured reasoning justified by better accuracy?</a:t>
             </a:r>
-            <a:endParaRPr lang="en-US" dirty="0"/>
           </a:p>
         </p:txBody>
       </p:sp>
@@ -1198,7 +988,6 @@
               <a:rPr lang="en-US" dirty="0"/>
               <a:t>H1 and H3 concern correctness; H2 concerns computational cost.</a:t>
             </a:r>
-            <a:endParaRPr lang="en-US" dirty="0"/>
           </a:p>
         </p:txBody>
       </p:sp>
@@ -1286,7 +1075,6 @@
               <a:rPr lang="en-US" dirty="0"/>
               <a:t>Mention how reference answers were prepared and verified.</a:t>
             </a:r>
-            <a:endParaRPr lang="en-US" dirty="0"/>
           </a:p>
         </p:txBody>
       </p:sp>
@@ -1374,7 +1162,6 @@
               <a:rPr lang="en-US" dirty="0"/>
               <a:t>Replace the quoted templates with the exact prompt text from your notebook.</a:t>
             </a:r>
-            <a:endParaRPr lang="en-US" dirty="0"/>
           </a:p>
         </p:txBody>
       </p:sp>
@@ -1462,7 +1249,6 @@
               <a:rPr lang="en-US" dirty="0"/>
               <a:t>Mention sampling settings (temperature etc.) if you set them.</a:t>
             </a:r>
-            <a:endParaRPr lang="en-US" dirty="0"/>
           </a:p>
         </p:txBody>
       </p:sp>
@@ -1550,7 +1336,6 @@
               <a:rPr lang="en-US" dirty="0"/>
               <a:t>The table cells and chart values are placeholders. Replace them with the aggregated results from your DataFrame before presenting.</a:t>
             </a:r>
-            <a:endParaRPr lang="en-US" dirty="0"/>
           </a:p>
         </p:txBody>
       </p:sp>
@@ -1638,7 +1423,6 @@
               <a:rPr lang="en-US" dirty="0"/>
               <a:t>Replace the generic failure modes with specific question IDs from your error log.</a:t>
             </a:r>
-            <a:endParaRPr lang="en-US" dirty="0"/>
           </a:p>
         </p:txBody>
       </p:sp>
@@ -1726,7 +1510,6 @@
               <a:rPr lang="en-US" dirty="0"/>
               <a:t>State explicitly whether H1, H2 and H3 were supported by your data.</a:t>
             </a:r>
-            <a:endParaRPr lang="en-US" dirty="0"/>
           </a:p>
         </p:txBody>
       </p:sp>
@@ -1804,6 +1587,7 @@
         <a:solidFill>
           <a:srgbClr val="FFFFFF"/>
         </a:solidFill>
+        <a:effectLst/>
       </p:bgPr>
     </p:bg>
     <p:spTree>
@@ -1823,9 +1607,11 @@
       <p:sp>
         <p:nvSpPr>
           <p:cNvPr id="2" name="Text 0"/>
-          <p:cNvSpPr/>
+          <p:cNvSpPr>
+            <a:spLocks noGrp="1"/>
+          </p:cNvSpPr>
           <p:nvPr>
-            <p:ph idx="100" type="title" hasCustomPrompt="1"/>
+            <p:ph type="title" idx="100" hasCustomPrompt="1"/>
           </p:nvPr>
         </p:nvSpPr>
         <p:spPr>
@@ -1842,7 +1628,7 @@
         <p:txBody>
           <a:bodyPr wrap="square" rtlCol="0"/>
           <a:lstStyle>
-            <a:lvl1pPr algn="l" indent="0" marL="0">
+            <a:lvl1pPr marL="0" indent="0" algn="l">
               <a:buNone/>
               <a:defRPr lang="en-US" sz="3000" b="1" dirty="0">
                 <a:solidFill>
@@ -1855,7 +1641,7 @@
             </a:lvl1pPr>
           </a:lstStyle>
           <a:p>
-            <a:pPr algn="l" indent="0" marL="0">
+            <a:pPr marL="0" indent="0" algn="l">
               <a:buNone/>
             </a:pPr>
             <a:endParaRPr lang="en-US" sz="3000" dirty="0"/>
@@ -1883,7 +1669,7 @@
           <a:bodyPr wrap="square" lIns="0" tIns="0" rIns="0" bIns="0" rtlCol="0" anchor="ctr"/>
           <a:lstStyle/>
           <a:p>
-            <a:pPr indent="0" marL="0">
+            <a:pPr marL="0" indent="0">
               <a:buNone/>
             </a:pPr>
             <a:r>
@@ -1921,7 +1707,7 @@
           </a:prstGeom>
           <a:extLst>
             <a:ext uri="{C572A759-6A51-4108-AA02-DFA0A04FC94B}">
-              <ma14:wrappingTextBoxFlag xmlns:ma14="http://schemas.microsoft.com/office/mac/drawingml/2011/main" val="0"/>
+              <ma14:wrappingTextBoxFlag xmlns:ma14="http://schemas.microsoft.com/office/mac/drawingml/2011/main" xmlns="" val="0"/>
             </a:ext>
           </a:extLst>
         </p:spPr>
@@ -1942,8 +1728,8 @@
           <a:p>
             <a:pPr algn="l"/>
             <a:fld id="{F7021451-1387-4CA6-816F-3879F97B5CBC}" type="slidenum">
-              <a:rPr b="0" lang="en-US"/>
-              <a:t>1002</a:t>
+              <a:rPr lang="en-US" b="0"/>
+              <a:t>‹#›</a:t>
             </a:fld>
             <a:endParaRPr lang="en-US"/>
           </a:p>
@@ -1965,6 +1751,7 @@
         <a:solidFill>
           <a:srgbClr val="12263F"/>
         </a:solidFill>
+        <a:effectLst/>
       </p:bgPr>
     </p:bg>
     <p:spTree>
@@ -1984,9 +1771,11 @@
       <p:sp>
         <p:nvSpPr>
           <p:cNvPr id="2" name="Text 0"/>
-          <p:cNvSpPr/>
+          <p:cNvSpPr>
+            <a:spLocks noGrp="1"/>
+          </p:cNvSpPr>
           <p:nvPr>
-            <p:ph idx="100" type="title" hasCustomPrompt="1"/>
+            <p:ph type="title" idx="100" hasCustomPrompt="1"/>
           </p:nvPr>
         </p:nvSpPr>
         <p:spPr>
@@ -2003,7 +1792,7 @@
         <p:txBody>
           <a:bodyPr wrap="square" rtlCol="0"/>
           <a:lstStyle>
-            <a:lvl1pPr algn="l" indent="0" marL="0">
+            <a:lvl1pPr marL="0" indent="0" algn="l">
               <a:buNone/>
               <a:defRPr lang="en-US" sz="3000" b="1" dirty="0">
                 <a:solidFill>
@@ -2016,7 +1805,7 @@
             </a:lvl1pPr>
           </a:lstStyle>
           <a:p>
-            <a:pPr algn="l" indent="0" marL="0">
+            <a:pPr marL="0" indent="0" algn="l">
               <a:buNone/>
             </a:pPr>
             <a:endParaRPr lang="en-US" sz="3000" dirty="0"/>
@@ -2044,7 +1833,7 @@
           <a:bodyPr wrap="square" lIns="0" tIns="0" rIns="0" bIns="0" rtlCol="0" anchor="ctr"/>
           <a:lstStyle/>
           <a:p>
-            <a:pPr indent="0" marL="0">
+            <a:pPr marL="0" indent="0">
               <a:buNone/>
             </a:pPr>
             <a:r>
@@ -2082,7 +1871,7 @@
           </a:prstGeom>
           <a:extLst>
             <a:ext uri="{C572A759-6A51-4108-AA02-DFA0A04FC94B}">
-              <ma14:wrappingTextBoxFlag xmlns:ma14="http://schemas.microsoft.com/office/mac/drawingml/2011/main" val="0"/>
+              <ma14:wrappingTextBoxFlag xmlns:ma14="http://schemas.microsoft.com/office/mac/drawingml/2011/main" xmlns="" val="0"/>
             </a:ext>
           </a:extLst>
         </p:spPr>
@@ -2103,8 +1892,8 @@
           <a:p>
             <a:pPr algn="l"/>
             <a:fld id="{F7021451-1387-4CA6-816F-3879F97B5CBC}" type="slidenum">
-              <a:rPr b="0" lang="en-US"/>
-              <a:t>1003</a:t>
+              <a:rPr lang="en-US" b="0"/>
+              <a:t>‹#›</a:t>
             </a:fld>
             <a:endParaRPr lang="en-US"/>
           </a:p>
@@ -2126,6 +1915,7 @@
         <a:solidFill>
           <a:srgbClr val="12263F"/>
         </a:solidFill>
+        <a:effectLst/>
       </p:bgPr>
     </p:bg>
     <p:spTree>
@@ -2145,9 +1935,11 @@
       <p:sp>
         <p:nvSpPr>
           <p:cNvPr id="2" name="Text 0"/>
-          <p:cNvSpPr/>
+          <p:cNvSpPr>
+            <a:spLocks noGrp="1"/>
+          </p:cNvSpPr>
           <p:nvPr>
-            <p:ph idx="100" type="title" hasCustomPrompt="1"/>
+            <p:ph type="title" idx="100" hasCustomPrompt="1"/>
           </p:nvPr>
         </p:nvSpPr>
         <p:spPr>
@@ -2164,7 +1956,7 @@
         <p:txBody>
           <a:bodyPr wrap="square" rtlCol="0"/>
           <a:lstStyle>
-            <a:lvl1pPr algn="l" indent="0" marL="0">
+            <a:lvl1pPr marL="0" indent="0" algn="l">
               <a:buNone/>
               <a:defRPr lang="en-US" sz="3200" b="1" dirty="0">
                 <a:solidFill>
@@ -2177,7 +1969,7 @@
             </a:lvl1pPr>
           </a:lstStyle>
           <a:p>
-            <a:pPr algn="l" indent="0" marL="0">
+            <a:pPr marL="0" indent="0" algn="l">
               <a:buNone/>
             </a:pPr>
             <a:endParaRPr lang="en-US" sz="3200" dirty="0"/>
@@ -2195,6 +1987,11 @@
 <file path=ppt/slideMasters/slideMaster1.xml><?xml version="1.0" encoding="utf-8"?>
 <p:sldMaster xmlns:a="http://schemas.openxmlformats.org/drawingml/2006/main" xmlns:r="http://schemas.openxmlformats.org/officeDocument/2006/relationships" xmlns:p="http://schemas.openxmlformats.org/presentationml/2006/main">
   <p:cSld>
+    <p:bg>
+      <p:bgRef idx="1001">
+        <a:schemeClr val="bg1"/>
+      </p:bgRef>
+    </p:bg>
     <p:spTree>
       <p:nvGrpSpPr>
         <p:cNvPr id="1" name=""/>
@@ -2229,7 +2026,7 @@
           </a:prstGeom>
           <a:extLst>
             <a:ext uri="{C572A759-6A51-4108-AA02-DFA0A04FC94B}">
-              <ma14:wrappingTextBoxFlag xmlns:ma14="http://schemas.microsoft.com/office/mac/drawingml/2011/main" val="0"/>
+              <ma14:wrappingTextBoxFlag xmlns:ma14="http://schemas.microsoft.com/office/mac/drawingml/2011/main" xmlns="" val="0"/>
             </a:ext>
           </a:extLst>
         </p:spPr>
@@ -2250,8 +2047,8 @@
           <a:p>
             <a:pPr algn="l"/>
             <a:fld id="{F7021451-1387-4CA6-816F-3879F97B5CBC}" type="slidenum">
-              <a:rPr b="0" lang="en-US"/>
-              <a:t>null</a:t>
+              <a:rPr lang="en-US" b="0"/>
+              <a:t>‹#›</a:t>
             </a:fld>
             <a:endParaRPr lang="en-US"/>
           </a:p>
@@ -2540,9 +2337,11 @@
       <p:sp>
         <p:nvSpPr>
           <p:cNvPr id="2" name="Text 0"/>
-          <p:cNvSpPr/>
+          <p:cNvSpPr>
+            <a:spLocks noGrp="1"/>
+          </p:cNvSpPr>
           <p:nvPr>
-            <p:ph idx="100" type="title" hasCustomPrompt="1"/>
+            <p:ph type="title" idx="100" hasCustomPrompt="1"/>
           </p:nvPr>
         </p:nvSpPr>
         <p:spPr>
@@ -2560,7 +2359,7 @@
           <a:bodyPr wrap="square" lIns="0" tIns="0" rIns="0" bIns="0" rtlCol="0" anchor="t"/>
           <a:lstStyle/>
           <a:p>
-            <a:pPr algn="l" indent="0" marL="0">
+            <a:pPr marL="0" indent="0" algn="l">
               <a:buNone/>
             </a:pPr>
             <a:r>
@@ -2599,7 +2398,7 @@
           <a:bodyPr wrap="square" lIns="0" tIns="0" rIns="0" bIns="0" rtlCol="0" anchor="t"/>
           <a:lstStyle/>
           <a:p>
-            <a:pPr indent="0" marL="0">
+            <a:pPr marL="0" indent="0">
               <a:buNone/>
             </a:pPr>
             <a:r>
@@ -2626,7 +2425,7 @@
         <p:spPr>
           <a:xfrm>
             <a:off x="640080" y="3154680"/>
-            <a:ext cx="7863840" cy="320040"/>
+            <a:ext cx="7863840" cy="525780"/>
           </a:xfrm>
           <a:prstGeom prst="rect">
             <a:avLst/>
@@ -2638,7 +2437,7 @@
           <a:bodyPr wrap="square" lIns="0" tIns="0" rIns="0" bIns="0" rtlCol="0" anchor="t"/>
           <a:lstStyle/>
           <a:p>
-            <a:pPr indent="0" marL="0">
+            <a:pPr marL="0" indent="0">
               <a:buNone/>
             </a:pPr>
             <a:r>
@@ -2650,7 +2449,20 @@
                 <a:ea typeface="Calibri" pitchFamily="34" charset="-122"/>
                 <a:cs typeface="Calibri" pitchFamily="34" charset="-120"/>
               </a:rPr>
-              <a:t>Presented by: [Your Name]  |  [Roll No.]</a:t>
+              <a:t>Presented by: BHAVYA JHA  |  [MT/AI/10009/26]</a:t>
+            </a:r>
+          </a:p>
+          <a:p>
+            <a:r>
+              <a:rPr lang="en-US" sz="1400" dirty="0">
+                <a:solidFill>
+                  <a:srgbClr val="CADCFC"/>
+                </a:solidFill>
+                <a:latin typeface="Calibri" pitchFamily="34" charset="0"/>
+                <a:ea typeface="Calibri" pitchFamily="34" charset="-122"/>
+                <a:cs typeface="Calibri" pitchFamily="34" charset="-120"/>
+              </a:rPr>
+              <a:t>                          HARSHITA      |  [MT/AI/10036/26]</a:t>
             </a:r>
             <a:endParaRPr lang="en-US" sz="1400" dirty="0"/>
           </a:p>
@@ -2704,7 +2516,7 @@
           <a:bodyPr wrap="square" lIns="0" tIns="0" rIns="0" bIns="0" rtlCol="0" anchor="ctr"/>
           <a:lstStyle/>
           <a:p>
-            <a:pPr algn="ctr" indent="0" marL="0">
+            <a:pPr marL="0" indent="0" algn="ctr">
               <a:buNone/>
             </a:pPr>
             <a:r>
@@ -2743,7 +2555,7 @@
           <a:bodyPr wrap="square" lIns="0" tIns="0" rIns="0" bIns="0" rtlCol="0" anchor="ctr"/>
           <a:lstStyle/>
           <a:p>
-            <a:pPr algn="ctr" indent="0" marL="0">
+            <a:pPr marL="0" indent="0" algn="ctr">
               <a:buNone/>
             </a:pPr>
             <a:r>
@@ -2809,7 +2621,7 @@
           <a:bodyPr wrap="square" lIns="0" tIns="0" rIns="0" bIns="0" rtlCol="0" anchor="ctr"/>
           <a:lstStyle/>
           <a:p>
-            <a:pPr algn="ctr" indent="0" marL="0">
+            <a:pPr marL="0" indent="0" algn="ctr">
               <a:buNone/>
             </a:pPr>
             <a:r>
@@ -2855,9 +2667,11 @@
       <p:sp>
         <p:nvSpPr>
           <p:cNvPr id="2" name="Text 0"/>
-          <p:cNvSpPr/>
+          <p:cNvSpPr>
+            <a:spLocks noGrp="1"/>
+          </p:cNvSpPr>
           <p:nvPr>
-            <p:ph idx="100" type="title" hasCustomPrompt="1"/>
+            <p:ph type="title" idx="100" hasCustomPrompt="1"/>
           </p:nvPr>
         </p:nvSpPr>
         <p:spPr>
@@ -2875,7 +2689,7 @@
           <a:bodyPr wrap="square" lIns="0" tIns="0" rIns="0" bIns="0" rtlCol="0" anchor="ctr"/>
           <a:lstStyle/>
           <a:p>
-            <a:pPr algn="l" indent="0" marL="0">
+            <a:pPr marL="0" indent="0" algn="l">
               <a:buNone/>
             </a:pPr>
             <a:r>
@@ -2966,7 +2780,7 @@
           <a:bodyPr wrap="square" lIns="0" tIns="0" rIns="0" bIns="0" rtlCol="0" anchor="ctr"/>
           <a:lstStyle/>
           <a:p>
-            <a:pPr algn="ctr" indent="0" marL="0">
+            <a:pPr marL="0" indent="0" algn="ctr">
               <a:buNone/>
             </a:pPr>
             <a:r>
@@ -3005,7 +2819,7 @@
           <a:bodyPr wrap="square" lIns="0" tIns="0" rIns="0" bIns="0" rtlCol="0" anchor="ctr"/>
           <a:lstStyle/>
           <a:p>
-            <a:pPr indent="0" marL="0">
+            <a:pPr marL="0" indent="0">
               <a:buNone/>
             </a:pPr>
             <a:r>
@@ -3044,7 +2858,7 @@
           <a:bodyPr wrap="square" lIns="0" tIns="0" rIns="0" bIns="0" rtlCol="0" anchor="t"/>
           <a:lstStyle/>
           <a:p>
-            <a:pPr indent="0" marL="0">
+            <a:pPr marL="0" indent="0">
               <a:buNone/>
             </a:pPr>
             <a:r>
@@ -3135,7 +2949,7 @@
           <a:bodyPr wrap="square" lIns="0" tIns="0" rIns="0" bIns="0" rtlCol="0" anchor="ctr"/>
           <a:lstStyle/>
           <a:p>
-            <a:pPr algn="ctr" indent="0" marL="0">
+            <a:pPr marL="0" indent="0" algn="ctr">
               <a:buNone/>
             </a:pPr>
             <a:r>
@@ -3174,7 +2988,7 @@
           <a:bodyPr wrap="square" lIns="0" tIns="0" rIns="0" bIns="0" rtlCol="0" anchor="ctr"/>
           <a:lstStyle/>
           <a:p>
-            <a:pPr indent="0" marL="0">
+            <a:pPr marL="0" indent="0">
               <a:buNone/>
             </a:pPr>
             <a:r>
@@ -3213,7 +3027,7 @@
           <a:bodyPr wrap="square" lIns="0" tIns="0" rIns="0" bIns="0" rtlCol="0" anchor="t"/>
           <a:lstStyle/>
           <a:p>
-            <a:pPr indent="0" marL="0">
+            <a:pPr marL="0" indent="0">
               <a:buNone/>
             </a:pPr>
             <a:r>
@@ -3304,7 +3118,7 @@
           <a:bodyPr wrap="square" lIns="0" tIns="0" rIns="0" bIns="0" rtlCol="0" anchor="ctr"/>
           <a:lstStyle/>
           <a:p>
-            <a:pPr algn="ctr" indent="0" marL="0">
+            <a:pPr marL="0" indent="0" algn="ctr">
               <a:buNone/>
             </a:pPr>
             <a:r>
@@ -3343,7 +3157,7 @@
           <a:bodyPr wrap="square" lIns="0" tIns="0" rIns="0" bIns="0" rtlCol="0" anchor="ctr"/>
           <a:lstStyle/>
           <a:p>
-            <a:pPr indent="0" marL="0">
+            <a:pPr marL="0" indent="0">
               <a:buNone/>
             </a:pPr>
             <a:r>
@@ -3382,7 +3196,7 @@
           <a:bodyPr wrap="square" lIns="0" tIns="0" rIns="0" bIns="0" rtlCol="0" anchor="t"/>
           <a:lstStyle/>
           <a:p>
-            <a:pPr indent="0" marL="0">
+            <a:pPr marL="0" indent="0">
               <a:buNone/>
             </a:pPr>
             <a:r>
@@ -3473,7 +3287,7 @@
           <a:bodyPr wrap="square" lIns="0" tIns="0" rIns="0" bIns="0" rtlCol="0" anchor="ctr"/>
           <a:lstStyle/>
           <a:p>
-            <a:pPr algn="ctr" indent="0" marL="0">
+            <a:pPr marL="0" indent="0" algn="ctr">
               <a:buNone/>
             </a:pPr>
             <a:r>
@@ -3512,7 +3326,7 @@
           <a:bodyPr wrap="square" lIns="0" tIns="0" rIns="0" bIns="0" rtlCol="0" anchor="ctr"/>
           <a:lstStyle/>
           <a:p>
-            <a:pPr indent="0" marL="0">
+            <a:pPr marL="0" indent="0">
               <a:buNone/>
             </a:pPr>
             <a:r>
@@ -3551,7 +3365,7 @@
           <a:bodyPr wrap="square" lIns="0" tIns="0" rIns="0" bIns="0" rtlCol="0" anchor="t"/>
           <a:lstStyle/>
           <a:p>
-            <a:pPr indent="0" marL="0">
+            <a:pPr marL="0" indent="0">
               <a:buNone/>
             </a:pPr>
             <a:r>
@@ -3589,7 +3403,7 @@
           </a:prstGeom>
           <a:extLst>
             <a:ext uri="{C572A759-6A51-4108-AA02-DFA0A04FC94B}">
-              <ma14:wrappingTextBoxFlag xmlns:ma14="http://schemas.microsoft.com/office/mac/drawingml/2011/main" val="0"/>
+              <ma14:wrappingTextBoxFlag xmlns:ma14="http://schemas.microsoft.com/office/mac/drawingml/2011/main" xmlns="" val="0"/>
             </a:ext>
           </a:extLst>
         </p:spPr>
@@ -3610,7 +3424,7 @@
           <a:p>
             <a:pPr algn="l"/>
             <a:fld id="{F7021451-1387-4CA6-816F-3879F97B5CBC}" type="slidenum">
-              <a:rPr b="0" lang="en-US"/>
+              <a:rPr lang="en-US" b="0"/>
               <a:t>10</a:t>
             </a:fld>
             <a:endParaRPr lang="en-US"/>
@@ -3645,9 +3459,11 @@
       <p:sp>
         <p:nvSpPr>
           <p:cNvPr id="2" name="Text 0"/>
-          <p:cNvSpPr/>
+          <p:cNvSpPr>
+            <a:spLocks noGrp="1"/>
+          </p:cNvSpPr>
           <p:nvPr>
-            <p:ph idx="100" type="title" hasCustomPrompt="1"/>
+            <p:ph type="title" idx="100" hasCustomPrompt="1"/>
           </p:nvPr>
         </p:nvSpPr>
         <p:spPr>
@@ -3665,7 +3481,7 @@
           <a:bodyPr wrap="square" lIns="0" tIns="0" rIns="0" bIns="0" rtlCol="0" anchor="ctr"/>
           <a:lstStyle/>
           <a:p>
-            <a:pPr algn="l" indent="0" marL="0">
+            <a:pPr marL="0" indent="0" algn="l">
               <a:buNone/>
             </a:pPr>
             <a:r>
@@ -3729,7 +3545,7 @@
           <a:bodyPr wrap="square" lIns="0" tIns="0" rIns="0" bIns="0" rtlCol="0" anchor="ctr"/>
           <a:lstStyle/>
           <a:p>
-            <a:pPr algn="ctr" indent="0" marL="0">
+            <a:pPr marL="0" indent="0" algn="ctr">
               <a:buNone/>
             </a:pPr>
             <a:r>
@@ -3768,7 +3584,7 @@
           <a:bodyPr wrap="square" lIns="0" tIns="0" rIns="0" bIns="0" rtlCol="0" anchor="t"/>
           <a:lstStyle/>
           <a:p>
-            <a:pPr indent="0" marL="0">
+            <a:pPr marL="0" indent="0">
               <a:buNone/>
             </a:pPr>
             <a:r>
@@ -3807,7 +3623,7 @@
           <a:bodyPr wrap="square" lIns="0" tIns="0" rIns="0" bIns="0" rtlCol="0" anchor="t"/>
           <a:lstStyle/>
           <a:p>
-            <a:pPr indent="0" marL="0">
+            <a:pPr marL="0" indent="0">
               <a:buNone/>
             </a:pPr>
             <a:r>
@@ -3871,7 +3687,7 @@
           <a:bodyPr wrap="square" lIns="0" tIns="0" rIns="0" bIns="0" rtlCol="0" anchor="ctr"/>
           <a:lstStyle/>
           <a:p>
-            <a:pPr algn="ctr" indent="0" marL="0">
+            <a:pPr marL="0" indent="0" algn="ctr">
               <a:buNone/>
             </a:pPr>
             <a:r>
@@ -3910,7 +3726,7 @@
           <a:bodyPr wrap="square" lIns="0" tIns="0" rIns="0" bIns="0" rtlCol="0" anchor="t"/>
           <a:lstStyle/>
           <a:p>
-            <a:pPr indent="0" marL="0">
+            <a:pPr marL="0" indent="0">
               <a:buNone/>
             </a:pPr>
             <a:r>
@@ -3949,7 +3765,7 @@
           <a:bodyPr wrap="square" lIns="0" tIns="0" rIns="0" bIns="0" rtlCol="0" anchor="t"/>
           <a:lstStyle/>
           <a:p>
-            <a:pPr indent="0" marL="0">
+            <a:pPr marL="0" indent="0">
               <a:buNone/>
             </a:pPr>
             <a:r>
@@ -4013,7 +3829,7 @@
           <a:bodyPr wrap="square" lIns="0" tIns="0" rIns="0" bIns="0" rtlCol="0" anchor="ctr"/>
           <a:lstStyle/>
           <a:p>
-            <a:pPr algn="ctr" indent="0" marL="0">
+            <a:pPr marL="0" indent="0" algn="ctr">
               <a:buNone/>
             </a:pPr>
             <a:r>
@@ -4052,7 +3868,7 @@
           <a:bodyPr wrap="square" lIns="0" tIns="0" rIns="0" bIns="0" rtlCol="0" anchor="t"/>
           <a:lstStyle/>
           <a:p>
-            <a:pPr indent="0" marL="0">
+            <a:pPr marL="0" indent="0">
               <a:buNone/>
             </a:pPr>
             <a:r>
@@ -4091,7 +3907,7 @@
           <a:bodyPr wrap="square" lIns="0" tIns="0" rIns="0" bIns="0" rtlCol="0" anchor="t"/>
           <a:lstStyle/>
           <a:p>
-            <a:pPr indent="0" marL="0">
+            <a:pPr marL="0" indent="0">
               <a:buNone/>
             </a:pPr>
             <a:r>
@@ -4157,7 +3973,7 @@
           <a:bodyPr wrap="square" lIns="0" tIns="0" rIns="0" bIns="0" rtlCol="0" anchor="t"/>
           <a:lstStyle/>
           <a:p>
-            <a:pPr indent="0" marL="0">
+            <a:pPr marL="0" indent="0">
               <a:buNone/>
             </a:pPr>
             <a:r>
@@ -4196,7 +4012,7 @@
           <a:bodyPr wrap="square" lIns="0" tIns="0" rIns="0" bIns="0" rtlCol="0" anchor="t"/>
           <a:lstStyle/>
           <a:p>
-            <a:pPr indent="0" marL="0">
+            <a:pPr marL="0" indent="0">
               <a:buNone/>
             </a:pPr>
             <a:r>
@@ -4235,7 +4051,7 @@
           <a:bodyPr wrap="square" lIns="0" tIns="0" rIns="0" bIns="0" rtlCol="0" anchor="t"/>
           <a:lstStyle/>
           <a:p>
-            <a:pPr indent="0" marL="0">
+            <a:pPr marL="0" indent="0">
               <a:buNone/>
             </a:pPr>
             <a:r>
@@ -4274,7 +4090,7 @@
           <a:bodyPr wrap="square" lIns="0" tIns="0" rIns="0" bIns="0" rtlCol="0" anchor="t"/>
           <a:lstStyle/>
           <a:p>
-            <a:pPr indent="0" marL="0">
+            <a:pPr marL="0" indent="0">
               <a:buNone/>
             </a:pPr>
             <a:r>
@@ -4313,7 +4129,7 @@
           <a:bodyPr wrap="square" lIns="0" tIns="0" rIns="0" bIns="0" rtlCol="0" anchor="t"/>
           <a:lstStyle/>
           <a:p>
-            <a:pPr indent="0" marL="0">
+            <a:pPr marL="0" indent="0">
               <a:buNone/>
             </a:pPr>
             <a:r>
@@ -4352,7 +4168,7 @@
           <a:bodyPr wrap="square" lIns="0" tIns="0" rIns="0" bIns="0" rtlCol="0" anchor="t"/>
           <a:lstStyle/>
           <a:p>
-            <a:pPr indent="0" marL="0">
+            <a:pPr marL="0" indent="0">
               <a:buNone/>
             </a:pPr>
             <a:r>
@@ -4390,7 +4206,7 @@
           </a:prstGeom>
           <a:extLst>
             <a:ext uri="{C572A759-6A51-4108-AA02-DFA0A04FC94B}">
-              <ma14:wrappingTextBoxFlag xmlns:ma14="http://schemas.microsoft.com/office/mac/drawingml/2011/main" val="0"/>
+              <ma14:wrappingTextBoxFlag xmlns:ma14="http://schemas.microsoft.com/office/mac/drawingml/2011/main" xmlns="" val="0"/>
             </a:ext>
           </a:extLst>
         </p:spPr>
@@ -4411,7 +4227,7 @@
           <a:p>
             <a:pPr algn="l"/>
             <a:fld id="{F7021451-1387-4CA6-816F-3879F97B5CBC}" type="slidenum">
-              <a:rPr b="0" lang="en-US"/>
+              <a:rPr lang="en-US" b="0"/>
               <a:t>2</a:t>
             </a:fld>
             <a:endParaRPr lang="en-US"/>
@@ -4446,9 +4262,11 @@
       <p:sp>
         <p:nvSpPr>
           <p:cNvPr id="2" name="Text 0"/>
-          <p:cNvSpPr/>
+          <p:cNvSpPr>
+            <a:spLocks noGrp="1"/>
+          </p:cNvSpPr>
           <p:nvPr>
-            <p:ph idx="100" type="title" hasCustomPrompt="1"/>
+            <p:ph type="title" idx="100" hasCustomPrompt="1"/>
           </p:nvPr>
         </p:nvSpPr>
         <p:spPr>
@@ -4466,7 +4284,7 @@
           <a:bodyPr wrap="square" lIns="0" tIns="0" rIns="0" bIns="0" rtlCol="0" anchor="ctr"/>
           <a:lstStyle/>
           <a:p>
-            <a:pPr algn="l" indent="0" marL="0">
+            <a:pPr marL="0" indent="0" algn="l">
               <a:buNone/>
             </a:pPr>
             <a:r>
@@ -4532,11 +4350,11 @@
           <a:bodyPr wrap="square" lIns="0" tIns="0" rIns="0" bIns="0" rtlCol="0" anchor="t"/>
           <a:lstStyle/>
           <a:p>
-            <a:pPr indent="0" marL="0">
+            <a:pPr marL="0" indent="0">
               <a:buNone/>
             </a:pPr>
             <a:r>
-              <a:rPr lang="en-US" sz="1100" b="1" spc="200" kern="0" dirty="0">
+              <a:rPr lang="en-US" sz="1100" b="1" kern="0" spc="200" dirty="0">
                 <a:solidFill>
                   <a:srgbClr val="E09F3E"/>
                 </a:solidFill>
@@ -4571,7 +4389,7 @@
           <a:bodyPr wrap="square" lIns="0" tIns="0" rIns="0" bIns="0" rtlCol="0" anchor="t"/>
           <a:lstStyle/>
           <a:p>
-            <a:pPr indent="0" marL="0">
+            <a:pPr marL="0" indent="0">
               <a:buNone/>
             </a:pPr>
             <a:r>
@@ -4662,7 +4480,7 @@
           <a:bodyPr wrap="square" lIns="0" tIns="0" rIns="0" bIns="0" rtlCol="0" anchor="ctr"/>
           <a:lstStyle/>
           <a:p>
-            <a:pPr algn="ctr" indent="0" marL="0">
+            <a:pPr marL="0" indent="0" algn="ctr">
               <a:buNone/>
             </a:pPr>
             <a:r>
@@ -4701,7 +4519,7 @@
           <a:bodyPr wrap="square" lIns="0" tIns="0" rIns="0" bIns="0" rtlCol="0" anchor="ctr"/>
           <a:lstStyle/>
           <a:p>
-            <a:pPr indent="0" marL="0">
+            <a:pPr marL="0" indent="0">
               <a:buNone/>
             </a:pPr>
             <a:r>
@@ -4740,7 +4558,7 @@
           <a:bodyPr wrap="square" lIns="0" tIns="0" rIns="0" bIns="0" rtlCol="0" anchor="t"/>
           <a:lstStyle/>
           <a:p>
-            <a:pPr indent="0" marL="0">
+            <a:pPr marL="0" indent="0">
               <a:buNone/>
             </a:pPr>
             <a:r>
@@ -4831,7 +4649,7 @@
           <a:bodyPr wrap="square" lIns="0" tIns="0" rIns="0" bIns="0" rtlCol="0" anchor="ctr"/>
           <a:lstStyle/>
           <a:p>
-            <a:pPr algn="ctr" indent="0" marL="0">
+            <a:pPr marL="0" indent="0" algn="ctr">
               <a:buNone/>
             </a:pPr>
             <a:r>
@@ -4870,7 +4688,7 @@
           <a:bodyPr wrap="square" lIns="0" tIns="0" rIns="0" bIns="0" rtlCol="0" anchor="ctr"/>
           <a:lstStyle/>
           <a:p>
-            <a:pPr indent="0" marL="0">
+            <a:pPr marL="0" indent="0">
               <a:buNone/>
             </a:pPr>
             <a:r>
@@ -4909,7 +4727,7 @@
           <a:bodyPr wrap="square" lIns="0" tIns="0" rIns="0" bIns="0" rtlCol="0" anchor="t"/>
           <a:lstStyle/>
           <a:p>
-            <a:pPr indent="0" marL="0">
+            <a:pPr marL="0" indent="0">
               <a:buNone/>
             </a:pPr>
             <a:r>
@@ -5000,7 +4818,7 @@
           <a:bodyPr wrap="square" lIns="0" tIns="0" rIns="0" bIns="0" rtlCol="0" anchor="ctr"/>
           <a:lstStyle/>
           <a:p>
-            <a:pPr algn="ctr" indent="0" marL="0">
+            <a:pPr marL="0" indent="0" algn="ctr">
               <a:buNone/>
             </a:pPr>
             <a:r>
@@ -5039,7 +4857,7 @@
           <a:bodyPr wrap="square" lIns="0" tIns="0" rIns="0" bIns="0" rtlCol="0" anchor="ctr"/>
           <a:lstStyle/>
           <a:p>
-            <a:pPr indent="0" marL="0">
+            <a:pPr marL="0" indent="0">
               <a:buNone/>
             </a:pPr>
             <a:r>
@@ -5078,7 +4896,7 @@
           <a:bodyPr wrap="square" lIns="0" tIns="0" rIns="0" bIns="0" rtlCol="0" anchor="t"/>
           <a:lstStyle/>
           <a:p>
-            <a:pPr indent="0" marL="0">
+            <a:pPr marL="0" indent="0">
               <a:buNone/>
             </a:pPr>
             <a:r>
@@ -5116,7 +4934,7 @@
           </a:prstGeom>
           <a:extLst>
             <a:ext uri="{C572A759-6A51-4108-AA02-DFA0A04FC94B}">
-              <ma14:wrappingTextBoxFlag xmlns:ma14="http://schemas.microsoft.com/office/mac/drawingml/2011/main" val="0"/>
+              <ma14:wrappingTextBoxFlag xmlns:ma14="http://schemas.microsoft.com/office/mac/drawingml/2011/main" xmlns="" val="0"/>
             </a:ext>
           </a:extLst>
         </p:spPr>
@@ -5137,7 +4955,7 @@
           <a:p>
             <a:pPr algn="l"/>
             <a:fld id="{F7021451-1387-4CA6-816F-3879F97B5CBC}" type="slidenum">
-              <a:rPr b="0" lang="en-US"/>
+              <a:rPr lang="en-US" b="0"/>
               <a:t>3</a:t>
             </a:fld>
             <a:endParaRPr lang="en-US"/>
@@ -5172,9 +4990,11 @@
       <p:sp>
         <p:nvSpPr>
           <p:cNvPr id="2" name="Text 0"/>
-          <p:cNvSpPr/>
+          <p:cNvSpPr>
+            <a:spLocks noGrp="1"/>
+          </p:cNvSpPr>
           <p:nvPr>
-            <p:ph idx="100" type="title" hasCustomPrompt="1"/>
+            <p:ph type="title" idx="100" hasCustomPrompt="1"/>
           </p:nvPr>
         </p:nvSpPr>
         <p:spPr>
@@ -5192,7 +5012,7 @@
           <a:bodyPr wrap="square" lIns="0" tIns="0" rIns="0" bIns="0" rtlCol="0" anchor="ctr"/>
           <a:lstStyle/>
           <a:p>
-            <a:pPr algn="l" indent="0" marL="0">
+            <a:pPr marL="0" indent="0" algn="l">
               <a:buNone/>
             </a:pPr>
             <a:r>
@@ -5226,16 +5046,34 @@
         </p:nvGraphicFramePr>
         <p:xfrm>
           <a:off x="457200" y="1188720"/>
-          <a:ext cx="5486400" cy="914400"/>
+          <a:ext cx="5486400" cy="2514600"/>
         </p:xfrm>
         <a:graphic>
           <a:graphicData uri="http://schemas.openxmlformats.org/drawingml/2006/table">
             <a:tbl>
               <a:tblPr/>
               <a:tblGrid>
-                <a:gridCol w="1645920"/>
-                <a:gridCol w="2926080"/>
-                <a:gridCol w="914400"/>
+                <a:gridCol w="1645920">
+                  <a:extLst>
+                    <a:ext uri="{9D8B030D-6E8A-4147-A177-3AD203B41FA5}">
+                      <a16:colId xmlns:a16="http://schemas.microsoft.com/office/drawing/2014/main" val="20000"/>
+                    </a:ext>
+                  </a:extLst>
+                </a:gridCol>
+                <a:gridCol w="2926080">
+                  <a:extLst>
+                    <a:ext uri="{9D8B030D-6E8A-4147-A177-3AD203B41FA5}">
+                      <a16:colId xmlns:a16="http://schemas.microsoft.com/office/drawing/2014/main" val="20001"/>
+                    </a:ext>
+                  </a:extLst>
+                </a:gridCol>
+                <a:gridCol w="914400">
+                  <a:extLst>
+                    <a:ext uri="{9D8B030D-6E8A-4147-A177-3AD203B41FA5}">
+                      <a16:colId xmlns:a16="http://schemas.microsoft.com/office/drawing/2014/main" val="20002"/>
+                    </a:ext>
+                  </a:extLst>
+                </a:gridCol>
               </a:tblGrid>
               <a:tr h="502920">
                 <a:tc>
@@ -5243,7 +5081,7 @@
                     <a:bodyPr/>
                     <a:lstStyle/>
                     <a:p>
-                      <a:pPr algn="l" indent="0" marL="0">
+                      <a:pPr marL="0" indent="0" algn="l">
                         <a:buNone/>
                       </a:pPr>
                       <a:r>
@@ -5264,7 +5102,7 @@
                       </a:endParaRPr>
                     </a:p>
                   </a:txBody>
-                  <a:tcPr marL="91440" marR="91440" marT="0" marB="0" anchor="ctr">
+                  <a:tcPr marT="0" marB="0" anchor="ctr">
                     <a:lnL w="9525" cap="flat" cmpd="sng" algn="ctr">
                       <a:solidFill>
                         <a:srgbClr val="D5DCE4"/>
@@ -5311,7 +5149,7 @@
                     <a:bodyPr/>
                     <a:lstStyle/>
                     <a:p>
-                      <a:pPr algn="l" indent="0" marL="0">
+                      <a:pPr marL="0" indent="0" algn="l">
                         <a:buNone/>
                       </a:pPr>
                       <a:r>
@@ -5332,7 +5170,7 @@
                       </a:endParaRPr>
                     </a:p>
                   </a:txBody>
-                  <a:tcPr marL="91440" marR="91440" marT="0" marB="0" anchor="ctr">
+                  <a:tcPr marT="0" marB="0" anchor="ctr">
                     <a:lnL w="9525" cap="flat" cmpd="sng" algn="ctr">
                       <a:solidFill>
                         <a:srgbClr val="D5DCE4"/>
@@ -5379,7 +5217,7 @@
                     <a:bodyPr/>
                     <a:lstStyle/>
                     <a:p>
-                      <a:pPr algn="l" indent="0" marL="0">
+                      <a:pPr marL="0" indent="0" algn="l">
                         <a:buNone/>
                       </a:pPr>
                       <a:r>
@@ -5400,7 +5238,7 @@
                       </a:endParaRPr>
                     </a:p>
                   </a:txBody>
-                  <a:tcPr marL="91440" marR="91440" marT="0" marB="0" anchor="ctr">
+                  <a:tcPr marT="0" marB="0" anchor="ctr">
                     <a:lnL w="9525" cap="flat" cmpd="sng" algn="ctr">
                       <a:solidFill>
                         <a:srgbClr val="D5DCE4"/>
@@ -5442,6 +5280,11 @@
                     </a:solidFill>
                   </a:tcPr>
                 </a:tc>
+                <a:extLst>
+                  <a:ext uri="{0D108BD9-81ED-4DB2-BD59-A6C34878D82A}">
+                    <a16:rowId xmlns:a16="http://schemas.microsoft.com/office/drawing/2014/main" val="10000"/>
+                  </a:ext>
+                </a:extLst>
               </a:tr>
               <a:tr h="502920">
                 <a:tc>
@@ -5449,7 +5292,7 @@
                     <a:bodyPr/>
                     <a:lstStyle/>
                     <a:p>
-                      <a:pPr indent="0" marL="0">
+                      <a:pPr marL="0" indent="0">
                         <a:buNone/>
                       </a:pPr>
                       <a:r>
@@ -5470,7 +5313,7 @@
                       </a:endParaRPr>
                     </a:p>
                   </a:txBody>
-                  <a:tcPr marL="91440" marR="91440" marT="0" marB="0" anchor="ctr">
+                  <a:tcPr marT="0" marB="0" anchor="ctr">
                     <a:lnL w="9525" cap="flat" cmpd="sng" algn="ctr">
                       <a:solidFill>
                         <a:srgbClr val="D5DCE4"/>
@@ -5514,7 +5357,7 @@
                     <a:bodyPr/>
                     <a:lstStyle/>
                     <a:p>
-                      <a:pPr indent="0" marL="0">
+                      <a:pPr marL="0" indent="0">
                         <a:buNone/>
                       </a:pPr>
                       <a:r>
@@ -5535,7 +5378,7 @@
                       </a:endParaRPr>
                     </a:p>
                   </a:txBody>
-                  <a:tcPr marL="91440" marR="91440" marT="0" marB="0" anchor="ctr">
+                  <a:tcPr marT="0" marB="0" anchor="ctr">
                     <a:lnL w="9525" cap="flat" cmpd="sng" algn="ctr">
                       <a:solidFill>
                         <a:srgbClr val="D5DCE4"/>
@@ -5579,7 +5422,7 @@
                     <a:bodyPr/>
                     <a:lstStyle/>
                     <a:p>
-                      <a:pPr algn="ctr" indent="0" marL="0">
+                      <a:pPr marL="0" indent="0" algn="ctr">
                         <a:buNone/>
                       </a:pPr>
                       <a:r>
@@ -5600,7 +5443,7 @@
                       </a:endParaRPr>
                     </a:p>
                   </a:txBody>
-                  <a:tcPr marL="91440" marR="91440" marT="0" marB="0" anchor="ctr">
+                  <a:tcPr marT="0" marB="0" anchor="ctr">
                     <a:lnL w="9525" cap="flat" cmpd="sng" algn="ctr">
                       <a:solidFill>
                         <a:srgbClr val="D5DCE4"/>
@@ -5639,6 +5482,11 @@
                     </a:lnB>
                   </a:tcPr>
                 </a:tc>
+                <a:extLst>
+                  <a:ext uri="{0D108BD9-81ED-4DB2-BD59-A6C34878D82A}">
+                    <a16:rowId xmlns:a16="http://schemas.microsoft.com/office/drawing/2014/main" val="10001"/>
+                  </a:ext>
+                </a:extLst>
               </a:tr>
               <a:tr h="502920">
                 <a:tc>
@@ -5646,7 +5494,7 @@
                     <a:bodyPr/>
                     <a:lstStyle/>
                     <a:p>
-                      <a:pPr indent="0" marL="0">
+                      <a:pPr marL="0" indent="0">
                         <a:buNone/>
                       </a:pPr>
                       <a:r>
@@ -5667,7 +5515,7 @@
                       </a:endParaRPr>
                     </a:p>
                   </a:txBody>
-                  <a:tcPr marL="91440" marR="91440" marT="0" marB="0" anchor="ctr">
+                  <a:tcPr marT="0" marB="0" anchor="ctr">
                     <a:lnL w="9525" cap="flat" cmpd="sng" algn="ctr">
                       <a:solidFill>
                         <a:srgbClr val="D5DCE4"/>
@@ -5711,7 +5559,7 @@
                     <a:bodyPr/>
                     <a:lstStyle/>
                     <a:p>
-                      <a:pPr indent="0" marL="0">
+                      <a:pPr marL="0" indent="0">
                         <a:buNone/>
                       </a:pPr>
                       <a:r>
@@ -5732,7 +5580,7 @@
                       </a:endParaRPr>
                     </a:p>
                   </a:txBody>
-                  <a:tcPr marL="91440" marR="91440" marT="0" marB="0" anchor="ctr">
+                  <a:tcPr marT="0" marB="0" anchor="ctr">
                     <a:lnL w="9525" cap="flat" cmpd="sng" algn="ctr">
                       <a:solidFill>
                         <a:srgbClr val="D5DCE4"/>
@@ -5776,7 +5624,7 @@
                     <a:bodyPr/>
                     <a:lstStyle/>
                     <a:p>
-                      <a:pPr algn="ctr" indent="0" marL="0">
+                      <a:pPr marL="0" indent="0" algn="ctr">
                         <a:buNone/>
                       </a:pPr>
                       <a:r>
@@ -5797,7 +5645,7 @@
                       </a:endParaRPr>
                     </a:p>
                   </a:txBody>
-                  <a:tcPr marL="91440" marR="91440" marT="0" marB="0" anchor="ctr">
+                  <a:tcPr marT="0" marB="0" anchor="ctr">
                     <a:lnL w="9525" cap="flat" cmpd="sng" algn="ctr">
                       <a:solidFill>
                         <a:srgbClr val="D5DCE4"/>
@@ -5836,6 +5684,11 @@
                     </a:lnB>
                   </a:tcPr>
                 </a:tc>
+                <a:extLst>
+                  <a:ext uri="{0D108BD9-81ED-4DB2-BD59-A6C34878D82A}">
+                    <a16:rowId xmlns:a16="http://schemas.microsoft.com/office/drawing/2014/main" val="10002"/>
+                  </a:ext>
+                </a:extLst>
               </a:tr>
               <a:tr h="502920">
                 <a:tc>
@@ -5843,7 +5696,7 @@
                     <a:bodyPr/>
                     <a:lstStyle/>
                     <a:p>
-                      <a:pPr indent="0" marL="0">
+                      <a:pPr marL="0" indent="0">
                         <a:buNone/>
                       </a:pPr>
                       <a:r>
@@ -5864,7 +5717,7 @@
                       </a:endParaRPr>
                     </a:p>
                   </a:txBody>
-                  <a:tcPr marL="91440" marR="91440" marT="0" marB="0" anchor="ctr">
+                  <a:tcPr marT="0" marB="0" anchor="ctr">
                     <a:lnL w="9525" cap="flat" cmpd="sng" algn="ctr">
                       <a:solidFill>
                         <a:srgbClr val="D5DCE4"/>
@@ -5908,7 +5761,7 @@
                     <a:bodyPr/>
                     <a:lstStyle/>
                     <a:p>
-                      <a:pPr indent="0" marL="0">
+                      <a:pPr marL="0" indent="0">
                         <a:buNone/>
                       </a:pPr>
                       <a:r>
@@ -5929,7 +5782,7 @@
                       </a:endParaRPr>
                     </a:p>
                   </a:txBody>
-                  <a:tcPr marL="91440" marR="91440" marT="0" marB="0" anchor="ctr">
+                  <a:tcPr marT="0" marB="0" anchor="ctr">
                     <a:lnL w="9525" cap="flat" cmpd="sng" algn="ctr">
                       <a:solidFill>
                         <a:srgbClr val="D5DCE4"/>
@@ -5973,7 +5826,7 @@
                     <a:bodyPr/>
                     <a:lstStyle/>
                     <a:p>
-                      <a:pPr algn="ctr" indent="0" marL="0">
+                      <a:pPr marL="0" indent="0" algn="ctr">
                         <a:buNone/>
                       </a:pPr>
                       <a:r>
@@ -5994,7 +5847,7 @@
                       </a:endParaRPr>
                     </a:p>
                   </a:txBody>
-                  <a:tcPr marL="91440" marR="91440" marT="0" marB="0" anchor="ctr">
+                  <a:tcPr marT="0" marB="0" anchor="ctr">
                     <a:lnL w="9525" cap="flat" cmpd="sng" algn="ctr">
                       <a:solidFill>
                         <a:srgbClr val="D5DCE4"/>
@@ -6033,6 +5886,11 @@
                     </a:lnB>
                   </a:tcPr>
                 </a:tc>
+                <a:extLst>
+                  <a:ext uri="{0D108BD9-81ED-4DB2-BD59-A6C34878D82A}">
+                    <a16:rowId xmlns:a16="http://schemas.microsoft.com/office/drawing/2014/main" val="10003"/>
+                  </a:ext>
+                </a:extLst>
               </a:tr>
               <a:tr h="502920">
                 <a:tc>
@@ -6040,7 +5898,7 @@
                     <a:bodyPr/>
                     <a:lstStyle/>
                     <a:p>
-                      <a:pPr indent="0" marL="0">
+                      <a:pPr marL="0" indent="0">
                         <a:buNone/>
                       </a:pPr>
                       <a:r>
@@ -6061,7 +5919,7 @@
                       </a:endParaRPr>
                     </a:p>
                   </a:txBody>
-                  <a:tcPr marL="91440" marR="91440" marT="0" marB="0" anchor="ctr">
+                  <a:tcPr marT="0" marB="0" anchor="ctr">
                     <a:lnL w="9525" cap="flat" cmpd="sng" algn="ctr">
                       <a:solidFill>
                         <a:srgbClr val="D5DCE4"/>
@@ -6105,7 +5963,7 @@
                     <a:bodyPr/>
                     <a:lstStyle/>
                     <a:p>
-                      <a:pPr indent="0" marL="0">
+                      <a:pPr marL="0" indent="0">
                         <a:buNone/>
                       </a:pPr>
                       <a:r>
@@ -6126,7 +5984,7 @@
                       </a:endParaRPr>
                     </a:p>
                   </a:txBody>
-                  <a:tcPr marL="91440" marR="91440" marT="0" marB="0" anchor="ctr">
+                  <a:tcPr marT="0" marB="0" anchor="ctr">
                     <a:lnL w="9525" cap="flat" cmpd="sng" algn="ctr">
                       <a:solidFill>
                         <a:srgbClr val="D5DCE4"/>
@@ -6170,7 +6028,7 @@
                     <a:bodyPr/>
                     <a:lstStyle/>
                     <a:p>
-                      <a:pPr algn="ctr" indent="0" marL="0">
+                      <a:pPr marL="0" indent="0" algn="ctr">
                         <a:buNone/>
                       </a:pPr>
                       <a:r>
@@ -6191,7 +6049,7 @@
                       </a:endParaRPr>
                     </a:p>
                   </a:txBody>
-                  <a:tcPr marL="91440" marR="91440" marT="0" marB="0" anchor="ctr">
+                  <a:tcPr marT="0" marB="0" anchor="ctr">
                     <a:lnL w="9525" cap="flat" cmpd="sng" algn="ctr">
                       <a:solidFill>
                         <a:srgbClr val="D5DCE4"/>
@@ -6230,6 +6088,11 @@
                     </a:lnB>
                   </a:tcPr>
                 </a:tc>
+                <a:extLst>
+                  <a:ext uri="{0D108BD9-81ED-4DB2-BD59-A6C34878D82A}">
+                    <a16:rowId xmlns:a16="http://schemas.microsoft.com/office/drawing/2014/main" val="10004"/>
+                  </a:ext>
+                </a:extLst>
               </a:tr>
             </a:tbl>
           </a:graphicData>
@@ -6264,7 +6127,7 @@
       </p:sp>
       <p:sp>
         <p:nvSpPr>
-          <p:cNvPr id="5" name="Text 2"/>
+          <p:cNvPr id="3" name="Text 2"/>
           <p:cNvSpPr txBox="1"/>
           <p:nvPr/>
         </p:nvSpPr>
@@ -6283,7 +6146,7 @@
           <a:bodyPr wrap="square" lIns="0" tIns="0" rIns="0" bIns="0" rtlCol="0" anchor="t"/>
           <a:lstStyle/>
           <a:p>
-            <a:pPr algn="ctr" indent="0" marL="0">
+            <a:pPr marL="0" indent="0" algn="ctr">
               <a:buNone/>
             </a:pPr>
             <a:r>
@@ -6322,7 +6185,7 @@
           <a:bodyPr wrap="square" lIns="0" tIns="0" rIns="0" bIns="0" rtlCol="0" anchor="t"/>
           <a:lstStyle/>
           <a:p>
-            <a:pPr algn="ctr" indent="0" marL="0">
+            <a:pPr marL="0" indent="0" algn="ctr">
               <a:buNone/>
             </a:pPr>
             <a:r>
@@ -6361,7 +6224,7 @@
           <a:bodyPr wrap="square" lIns="0" tIns="0" rIns="0" bIns="0" rtlCol="0" anchor="t"/>
           <a:lstStyle/>
           <a:p>
-            <a:pPr algn="ctr" indent="0" marL="0">
+            <a:pPr marL="0" indent="0" algn="ctr">
               <a:buNone/>
             </a:pPr>
             <a:r>
@@ -6400,7 +6263,7 @@
           <a:bodyPr wrap="square" lIns="0" tIns="0" rIns="0" bIns="0" rtlCol="0" anchor="t"/>
           <a:lstStyle/>
           <a:p>
-            <a:pPr indent="0" marL="0">
+            <a:pPr marL="0" indent="0">
               <a:buNone/>
             </a:pPr>
             <a:r>
@@ -6438,7 +6301,7 @@
           </a:prstGeom>
           <a:extLst>
             <a:ext uri="{C572A759-6A51-4108-AA02-DFA0A04FC94B}">
-              <ma14:wrappingTextBoxFlag xmlns:ma14="http://schemas.microsoft.com/office/mac/drawingml/2011/main" val="0"/>
+              <ma14:wrappingTextBoxFlag xmlns:ma14="http://schemas.microsoft.com/office/mac/drawingml/2011/main" xmlns="" val="0"/>
             </a:ext>
           </a:extLst>
         </p:spPr>
@@ -6459,7 +6322,7 @@
           <a:p>
             <a:pPr algn="l"/>
             <a:fld id="{F7021451-1387-4CA6-816F-3879F97B5CBC}" type="slidenum">
-              <a:rPr b="0" lang="en-US"/>
+              <a:rPr lang="en-US" b="0"/>
               <a:t>4</a:t>
             </a:fld>
             <a:endParaRPr lang="en-US"/>
@@ -6494,9 +6357,11 @@
       <p:sp>
         <p:nvSpPr>
           <p:cNvPr id="2" name="Text 0"/>
-          <p:cNvSpPr/>
+          <p:cNvSpPr>
+            <a:spLocks noGrp="1"/>
+          </p:cNvSpPr>
           <p:nvPr>
-            <p:ph idx="100" type="title" hasCustomPrompt="1"/>
+            <p:ph type="title" idx="100" hasCustomPrompt="1"/>
           </p:nvPr>
         </p:nvSpPr>
         <p:spPr>
@@ -6514,7 +6379,7 @@
           <a:bodyPr wrap="square" lIns="0" tIns="0" rIns="0" bIns="0" rtlCol="0" anchor="ctr"/>
           <a:lstStyle/>
           <a:p>
-            <a:pPr algn="l" indent="0" marL="0">
+            <a:pPr marL="0" indent="0" algn="l">
               <a:buNone/>
             </a:pPr>
             <a:r>
@@ -6580,7 +6445,7 @@
           <a:bodyPr wrap="square" lIns="0" tIns="0" rIns="0" bIns="0" rtlCol="0" anchor="ctr"/>
           <a:lstStyle/>
           <a:p>
-            <a:pPr algn="ctr" indent="0" marL="0">
+            <a:pPr marL="0" indent="0" algn="ctr">
               <a:buNone/>
             </a:pPr>
             <a:r>
@@ -6619,7 +6484,7 @@
           <a:bodyPr wrap="square" lIns="0" tIns="0" rIns="0" bIns="0" rtlCol="0" anchor="t"/>
           <a:lstStyle/>
           <a:p>
-            <a:pPr algn="ctr" indent="0" marL="0">
+            <a:pPr marL="0" indent="0" algn="ctr">
               <a:buNone/>
             </a:pPr>
             <a:r>
@@ -6709,7 +6574,7 @@
           <a:bodyPr wrap="square" lIns="0" tIns="0" rIns="0" bIns="0" rtlCol="0" anchor="ctr"/>
           <a:lstStyle/>
           <a:p>
-            <a:pPr algn="ctr" indent="0" marL="0">
+            <a:pPr marL="0" indent="0" algn="ctr">
               <a:buNone/>
             </a:pPr>
             <a:r>
@@ -6748,7 +6613,7 @@
           <a:bodyPr wrap="square" lIns="0" tIns="0" rIns="0" bIns="0" rtlCol="0" anchor="t"/>
           <a:lstStyle/>
           <a:p>
-            <a:pPr algn="ctr" indent="0" marL="0">
+            <a:pPr marL="0" indent="0" algn="ctr">
               <a:buNone/>
             </a:pPr>
             <a:r>
@@ -6838,7 +6703,7 @@
           <a:bodyPr wrap="square" lIns="0" tIns="0" rIns="0" bIns="0" rtlCol="0" anchor="ctr"/>
           <a:lstStyle/>
           <a:p>
-            <a:pPr algn="ctr" indent="0" marL="0">
+            <a:pPr marL="0" indent="0" algn="ctr">
               <a:buNone/>
             </a:pPr>
             <a:r>
@@ -6877,7 +6742,7 @@
           <a:bodyPr wrap="square" lIns="0" tIns="0" rIns="0" bIns="0" rtlCol="0" anchor="t"/>
           <a:lstStyle/>
           <a:p>
-            <a:pPr algn="ctr" indent="0" marL="0">
+            <a:pPr marL="0" indent="0" algn="ctr">
               <a:buNone/>
             </a:pPr>
             <a:r>
@@ -6967,7 +6832,7 @@
           <a:bodyPr wrap="square" lIns="0" tIns="0" rIns="0" bIns="0" rtlCol="0" anchor="ctr"/>
           <a:lstStyle/>
           <a:p>
-            <a:pPr algn="ctr" indent="0" marL="0">
+            <a:pPr marL="0" indent="0" algn="ctr">
               <a:buNone/>
             </a:pPr>
             <a:r>
@@ -7006,7 +6871,7 @@
           <a:bodyPr wrap="square" lIns="0" tIns="0" rIns="0" bIns="0" rtlCol="0" anchor="t"/>
           <a:lstStyle/>
           <a:p>
-            <a:pPr algn="ctr" indent="0" marL="0">
+            <a:pPr marL="0" indent="0" algn="ctr">
               <a:buNone/>
             </a:pPr>
             <a:r>
@@ -7096,7 +6961,7 @@
           <a:bodyPr wrap="square" lIns="0" tIns="0" rIns="0" bIns="0" rtlCol="0" anchor="ctr"/>
           <a:lstStyle/>
           <a:p>
-            <a:pPr algn="ctr" indent="0" marL="0">
+            <a:pPr marL="0" indent="0" algn="ctr">
               <a:buNone/>
             </a:pPr>
             <a:r>
@@ -7135,7 +7000,7 @@
           <a:bodyPr wrap="square" lIns="0" tIns="0" rIns="0" bIns="0" rtlCol="0" anchor="t"/>
           <a:lstStyle/>
           <a:p>
-            <a:pPr algn="ctr" indent="0" marL="0">
+            <a:pPr marL="0" indent="0" algn="ctr">
               <a:buNone/>
             </a:pPr>
             <a:r>
@@ -7174,7 +7039,7 @@
           <a:bodyPr wrap="square" lIns="0" tIns="0" rIns="0" bIns="0" rtlCol="0" anchor="t"/>
           <a:lstStyle/>
           <a:p>
-            <a:pPr indent="0" marL="0">
+            <a:pPr marL="0" indent="0">
               <a:buNone/>
             </a:pPr>
             <a:r>
@@ -7240,7 +7105,7 @@
           <a:bodyPr wrap="square" lIns="0" tIns="0" rIns="0" bIns="0" rtlCol="0" anchor="t"/>
           <a:lstStyle/>
           <a:p>
-            <a:pPr indent="0" marL="0">
+            <a:pPr marL="0" indent="0">
               <a:buNone/>
             </a:pPr>
             <a:r>
@@ -7279,7 +7144,7 @@
           <a:bodyPr wrap="square" lIns="0" tIns="0" rIns="0" bIns="0" rtlCol="0" anchor="t"/>
           <a:lstStyle/>
           <a:p>
-            <a:pPr indent="0" marL="0">
+            <a:pPr marL="0" indent="0">
               <a:buNone/>
             </a:pPr>
             <a:r>
@@ -7318,7 +7183,7 @@
           <a:bodyPr wrap="square" lIns="0" tIns="0" rIns="0" bIns="0" rtlCol="0" anchor="t"/>
           <a:lstStyle/>
           <a:p>
-            <a:pPr indent="0" marL="0">
+            <a:pPr marL="0" indent="0">
               <a:buNone/>
             </a:pPr>
             <a:r>
@@ -7384,7 +7249,7 @@
           <a:bodyPr wrap="square" lIns="0" tIns="0" rIns="0" bIns="0" rtlCol="0" anchor="t"/>
           <a:lstStyle/>
           <a:p>
-            <a:pPr indent="0" marL="0">
+            <a:pPr marL="0" indent="0">
               <a:buNone/>
             </a:pPr>
             <a:r>
@@ -7423,7 +7288,7 @@
           <a:bodyPr wrap="square" lIns="0" tIns="0" rIns="0" bIns="0" rtlCol="0" anchor="t"/>
           <a:lstStyle/>
           <a:p>
-            <a:pPr indent="0" marL="0">
+            <a:pPr marL="0" indent="0">
               <a:buNone/>
             </a:pPr>
             <a:r>
@@ -7462,7 +7327,7 @@
           <a:bodyPr wrap="square" lIns="0" tIns="0" rIns="0" bIns="0" rtlCol="0" anchor="t"/>
           <a:lstStyle/>
           <a:p>
-            <a:pPr indent="0" marL="0">
+            <a:pPr marL="0" indent="0">
               <a:buNone/>
             </a:pPr>
             <a:r>
@@ -7501,7 +7366,7 @@
           <a:bodyPr wrap="square" lIns="0" tIns="0" rIns="0" bIns="0" rtlCol="0" anchor="t"/>
           <a:lstStyle/>
           <a:p>
-            <a:pPr indent="0" marL="0">
+            <a:pPr marL="0" indent="0">
               <a:buNone/>
             </a:pPr>
             <a:r>
@@ -7521,7 +7386,7 @@
       </p:sp>
       <p:sp>
         <p:nvSpPr>
-          <p:cNvPr id="25" name="Slide Number Placeholder 0"/>
+          <p:cNvPr id="32" name="Slide Number Placeholder 0"/>
           <p:cNvSpPr>
             <a:spLocks noGrp="1"/>
           </p:cNvSpPr>
@@ -7539,7 +7404,7 @@
           </a:prstGeom>
           <a:extLst>
             <a:ext uri="{C572A759-6A51-4108-AA02-DFA0A04FC94B}">
-              <ma14:wrappingTextBoxFlag xmlns:ma14="http://schemas.microsoft.com/office/mac/drawingml/2011/main" val="0"/>
+              <ma14:wrappingTextBoxFlag xmlns:ma14="http://schemas.microsoft.com/office/mac/drawingml/2011/main" xmlns="" val="0"/>
             </a:ext>
           </a:extLst>
         </p:spPr>
@@ -7560,7 +7425,7 @@
           <a:p>
             <a:pPr algn="l"/>
             <a:fld id="{F7021451-1387-4CA6-816F-3879F97B5CBC}" type="slidenum">
-              <a:rPr b="0" lang="en-US"/>
+              <a:rPr lang="en-US" b="0"/>
               <a:t>5</a:t>
             </a:fld>
             <a:endParaRPr lang="en-US"/>
@@ -7595,9 +7460,11 @@
       <p:sp>
         <p:nvSpPr>
           <p:cNvPr id="2" name="Text 0"/>
-          <p:cNvSpPr/>
+          <p:cNvSpPr>
+            <a:spLocks noGrp="1"/>
+          </p:cNvSpPr>
           <p:nvPr>
-            <p:ph idx="100" type="title" hasCustomPrompt="1"/>
+            <p:ph type="title" idx="100" hasCustomPrompt="1"/>
           </p:nvPr>
         </p:nvSpPr>
         <p:spPr>
@@ -7615,7 +7482,7 @@
           <a:bodyPr wrap="square" lIns="0" tIns="0" rIns="0" bIns="0" rtlCol="0" anchor="ctr"/>
           <a:lstStyle/>
           <a:p>
-            <a:pPr algn="l" indent="0" marL="0">
+            <a:pPr marL="0" indent="0" algn="l">
               <a:buNone/>
             </a:pPr>
             <a:r>
@@ -7649,15 +7516,27 @@
         </p:nvGraphicFramePr>
         <p:xfrm>
           <a:off x="457200" y="1188720"/>
-          <a:ext cx="4480560" cy="914400"/>
+          <a:ext cx="4480560" cy="3017520"/>
         </p:xfrm>
         <a:graphic>
           <a:graphicData uri="http://schemas.openxmlformats.org/drawingml/2006/table">
             <a:tbl>
               <a:tblPr/>
               <a:tblGrid>
-                <a:gridCol w="1371600"/>
-                <a:gridCol w="3108960"/>
+                <a:gridCol w="1371600">
+                  <a:extLst>
+                    <a:ext uri="{9D8B030D-6E8A-4147-A177-3AD203B41FA5}">
+                      <a16:colId xmlns:a16="http://schemas.microsoft.com/office/drawing/2014/main" val="20000"/>
+                    </a:ext>
+                  </a:extLst>
+                </a:gridCol>
+                <a:gridCol w="3108960">
+                  <a:extLst>
+                    <a:ext uri="{9D8B030D-6E8A-4147-A177-3AD203B41FA5}">
+                      <a16:colId xmlns:a16="http://schemas.microsoft.com/office/drawing/2014/main" val="20001"/>
+                    </a:ext>
+                  </a:extLst>
+                </a:gridCol>
               </a:tblGrid>
               <a:tr h="502920">
                 <a:tc>
@@ -7665,7 +7544,7 @@
                     <a:bodyPr/>
                     <a:lstStyle/>
                     <a:p>
-                      <a:pPr algn="l" indent="0" marL="0">
+                      <a:pPr marL="0" indent="0" algn="l">
                         <a:buNone/>
                       </a:pPr>
                       <a:r>
@@ -7686,7 +7565,7 @@
                       </a:endParaRPr>
                     </a:p>
                   </a:txBody>
-                  <a:tcPr marL="91440" marR="91440" marT="0" marB="0" anchor="ctr">
+                  <a:tcPr marT="0" marB="0" anchor="ctr">
                     <a:lnL w="9525" cap="flat" cmpd="sng" algn="ctr">
                       <a:solidFill>
                         <a:srgbClr val="D5DCE4"/>
@@ -7733,7 +7612,7 @@
                     <a:bodyPr/>
                     <a:lstStyle/>
                     <a:p>
-                      <a:pPr algn="l" indent="0" marL="0">
+                      <a:pPr marL="0" indent="0" algn="l">
                         <a:buNone/>
                       </a:pPr>
                       <a:r>
@@ -7754,7 +7633,7 @@
                       </a:endParaRPr>
                     </a:p>
                   </a:txBody>
-                  <a:tcPr marL="91440" marR="91440" marT="0" marB="0" anchor="ctr">
+                  <a:tcPr marT="0" marB="0" anchor="ctr">
                     <a:lnL w="9525" cap="flat" cmpd="sng" algn="ctr">
                       <a:solidFill>
                         <a:srgbClr val="D5DCE4"/>
@@ -7796,6 +7675,11 @@
                     </a:solidFill>
                   </a:tcPr>
                 </a:tc>
+                <a:extLst>
+                  <a:ext uri="{0D108BD9-81ED-4DB2-BD59-A6C34878D82A}">
+                    <a16:rowId xmlns:a16="http://schemas.microsoft.com/office/drawing/2014/main" val="10000"/>
+                  </a:ext>
+                </a:extLst>
               </a:tr>
               <a:tr h="502920">
                 <a:tc>
@@ -7803,7 +7687,7 @@
                     <a:bodyPr/>
                     <a:lstStyle/>
                     <a:p>
-                      <a:pPr indent="0" marL="0">
+                      <a:pPr marL="0" indent="0">
                         <a:buNone/>
                       </a:pPr>
                       <a:r>
@@ -7824,7 +7708,7 @@
                       </a:endParaRPr>
                     </a:p>
                   </a:txBody>
-                  <a:tcPr marL="91440" marR="91440" marT="0" marB="0" anchor="ctr">
+                  <a:tcPr marT="0" marB="0" anchor="ctr">
                     <a:lnL w="9525" cap="flat" cmpd="sng" algn="ctr">
                       <a:solidFill>
                         <a:srgbClr val="D5DCE4"/>
@@ -7868,7 +7752,7 @@
                     <a:bodyPr/>
                     <a:lstStyle/>
                     <a:p>
-                      <a:pPr indent="0" marL="0">
+                      <a:pPr marL="0" indent="0">
                         <a:buNone/>
                       </a:pPr>
                       <a:r>
@@ -7889,7 +7773,7 @@
                       </a:endParaRPr>
                     </a:p>
                   </a:txBody>
-                  <a:tcPr marL="91440" marR="91440" marT="0" marB="0" anchor="ctr">
+                  <a:tcPr marT="0" marB="0" anchor="ctr">
                     <a:lnL w="9525" cap="flat" cmpd="sng" algn="ctr">
                       <a:solidFill>
                         <a:srgbClr val="D5DCE4"/>
@@ -7928,6 +7812,11 @@
                     </a:lnB>
                   </a:tcPr>
                 </a:tc>
+                <a:extLst>
+                  <a:ext uri="{0D108BD9-81ED-4DB2-BD59-A6C34878D82A}">
+                    <a16:rowId xmlns:a16="http://schemas.microsoft.com/office/drawing/2014/main" val="10001"/>
+                  </a:ext>
+                </a:extLst>
               </a:tr>
               <a:tr h="502920">
                 <a:tc>
@@ -7935,7 +7824,7 @@
                     <a:bodyPr/>
                     <a:lstStyle/>
                     <a:p>
-                      <a:pPr indent="0" marL="0">
+                      <a:pPr marL="0" indent="0">
                         <a:buNone/>
                       </a:pPr>
                       <a:r>
@@ -7956,7 +7845,7 @@
                       </a:endParaRPr>
                     </a:p>
                   </a:txBody>
-                  <a:tcPr marL="91440" marR="91440" marT="0" marB="0" anchor="ctr">
+                  <a:tcPr marT="0" marB="0" anchor="ctr">
                     <a:lnL w="9525" cap="flat" cmpd="sng" algn="ctr">
                       <a:solidFill>
                         <a:srgbClr val="D5DCE4"/>
@@ -8000,7 +7889,7 @@
                     <a:bodyPr/>
                     <a:lstStyle/>
                     <a:p>
-                      <a:pPr indent="0" marL="0">
+                      <a:pPr marL="0" indent="0">
                         <a:buNone/>
                       </a:pPr>
                       <a:r>
@@ -8021,7 +7910,7 @@
                       </a:endParaRPr>
                     </a:p>
                   </a:txBody>
-                  <a:tcPr marL="91440" marR="91440" marT="0" marB="0" anchor="ctr">
+                  <a:tcPr marT="0" marB="0" anchor="ctr">
                     <a:lnL w="9525" cap="flat" cmpd="sng" algn="ctr">
                       <a:solidFill>
                         <a:srgbClr val="D5DCE4"/>
@@ -8060,6 +7949,11 @@
                     </a:lnB>
                   </a:tcPr>
                 </a:tc>
+                <a:extLst>
+                  <a:ext uri="{0D108BD9-81ED-4DB2-BD59-A6C34878D82A}">
+                    <a16:rowId xmlns:a16="http://schemas.microsoft.com/office/drawing/2014/main" val="10002"/>
+                  </a:ext>
+                </a:extLst>
               </a:tr>
               <a:tr h="502920">
                 <a:tc>
@@ -8067,7 +7961,7 @@
                     <a:bodyPr/>
                     <a:lstStyle/>
                     <a:p>
-                      <a:pPr indent="0" marL="0">
+                      <a:pPr marL="0" indent="0">
                         <a:buNone/>
                       </a:pPr>
                       <a:r>
@@ -8088,7 +7982,7 @@
                       </a:endParaRPr>
                     </a:p>
                   </a:txBody>
-                  <a:tcPr marL="91440" marR="91440" marT="0" marB="0" anchor="ctr">
+                  <a:tcPr marT="0" marB="0" anchor="ctr">
                     <a:lnL w="9525" cap="flat" cmpd="sng" algn="ctr">
                       <a:solidFill>
                         <a:srgbClr val="D5DCE4"/>
@@ -8132,7 +8026,7 @@
                     <a:bodyPr/>
                     <a:lstStyle/>
                     <a:p>
-                      <a:pPr indent="0" marL="0">
+                      <a:pPr marL="0" indent="0">
                         <a:buNone/>
                       </a:pPr>
                       <a:r>
@@ -8153,7 +8047,7 @@
                       </a:endParaRPr>
                     </a:p>
                   </a:txBody>
-                  <a:tcPr marL="91440" marR="91440" marT="0" marB="0" anchor="ctr">
+                  <a:tcPr marT="0" marB="0" anchor="ctr">
                     <a:lnL w="9525" cap="flat" cmpd="sng" algn="ctr">
                       <a:solidFill>
                         <a:srgbClr val="D5DCE4"/>
@@ -8192,6 +8086,11 @@
                     </a:lnB>
                   </a:tcPr>
                 </a:tc>
+                <a:extLst>
+                  <a:ext uri="{0D108BD9-81ED-4DB2-BD59-A6C34878D82A}">
+                    <a16:rowId xmlns:a16="http://schemas.microsoft.com/office/drawing/2014/main" val="10003"/>
+                  </a:ext>
+                </a:extLst>
               </a:tr>
               <a:tr h="502920">
                 <a:tc>
@@ -8199,7 +8098,7 @@
                     <a:bodyPr/>
                     <a:lstStyle/>
                     <a:p>
-                      <a:pPr indent="0" marL="0">
+                      <a:pPr marL="0" indent="0">
                         <a:buNone/>
                       </a:pPr>
                       <a:r>
@@ -8220,7 +8119,7 @@
                       </a:endParaRPr>
                     </a:p>
                   </a:txBody>
-                  <a:tcPr marL="91440" marR="91440" marT="0" marB="0" anchor="ctr">
+                  <a:tcPr marT="0" marB="0" anchor="ctr">
                     <a:lnL w="9525" cap="flat" cmpd="sng" algn="ctr">
                       <a:solidFill>
                         <a:srgbClr val="D5DCE4"/>
@@ -8264,7 +8163,7 @@
                     <a:bodyPr/>
                     <a:lstStyle/>
                     <a:p>
-                      <a:pPr indent="0" marL="0">
+                      <a:pPr marL="0" indent="0">
                         <a:buNone/>
                       </a:pPr>
                       <a:r>
@@ -8285,7 +8184,7 @@
                       </a:endParaRPr>
                     </a:p>
                   </a:txBody>
-                  <a:tcPr marL="91440" marR="91440" marT="0" marB="0" anchor="ctr">
+                  <a:tcPr marT="0" marB="0" anchor="ctr">
                     <a:lnL w="9525" cap="flat" cmpd="sng" algn="ctr">
                       <a:solidFill>
                         <a:srgbClr val="D5DCE4"/>
@@ -8324,6 +8223,11 @@
                     </a:lnB>
                   </a:tcPr>
                 </a:tc>
+                <a:extLst>
+                  <a:ext uri="{0D108BD9-81ED-4DB2-BD59-A6C34878D82A}">
+                    <a16:rowId xmlns:a16="http://schemas.microsoft.com/office/drawing/2014/main" val="10004"/>
+                  </a:ext>
+                </a:extLst>
               </a:tr>
               <a:tr h="502920">
                 <a:tc>
@@ -8331,7 +8235,7 @@
                     <a:bodyPr/>
                     <a:lstStyle/>
                     <a:p>
-                      <a:pPr indent="0" marL="0">
+                      <a:pPr marL="0" indent="0">
                         <a:buNone/>
                       </a:pPr>
                       <a:r>
@@ -8352,7 +8256,7 @@
                       </a:endParaRPr>
                     </a:p>
                   </a:txBody>
-                  <a:tcPr marL="91440" marR="91440" marT="0" marB="0" anchor="ctr">
+                  <a:tcPr marT="0" marB="0" anchor="ctr">
                     <a:lnL w="9525" cap="flat" cmpd="sng" algn="ctr">
                       <a:solidFill>
                         <a:srgbClr val="D5DCE4"/>
@@ -8396,7 +8300,7 @@
                     <a:bodyPr/>
                     <a:lstStyle/>
                     <a:p>
-                      <a:pPr indent="0" marL="0">
+                      <a:pPr marL="0" indent="0">
                         <a:buNone/>
                       </a:pPr>
                       <a:r>
@@ -8417,7 +8321,7 @@
                       </a:endParaRPr>
                     </a:p>
                   </a:txBody>
-                  <a:tcPr marL="91440" marR="91440" marT="0" marB="0" anchor="ctr">
+                  <a:tcPr marT="0" marB="0" anchor="ctr">
                     <a:lnL w="9525" cap="flat" cmpd="sng" algn="ctr">
                       <a:solidFill>
                         <a:srgbClr val="D5DCE4"/>
@@ -8456,6 +8360,11 @@
                     </a:lnB>
                   </a:tcPr>
                 </a:tc>
+                <a:extLst>
+                  <a:ext uri="{0D108BD9-81ED-4DB2-BD59-A6C34878D82A}">
+                    <a16:rowId xmlns:a16="http://schemas.microsoft.com/office/drawing/2014/main" val="10005"/>
+                  </a:ext>
+                </a:extLst>
               </a:tr>
             </a:tbl>
           </a:graphicData>
@@ -8509,7 +8418,7 @@
           <a:bodyPr wrap="square" lIns="0" tIns="0" rIns="0" bIns="0" rtlCol="0" anchor="t"/>
           <a:lstStyle/>
           <a:p>
-            <a:pPr indent="0" marL="0">
+            <a:pPr marL="0" indent="0">
               <a:buNone/>
             </a:pPr>
             <a:r>
@@ -8548,7 +8457,7 @@
           <a:bodyPr wrap="square" lIns="0" tIns="0" rIns="0" bIns="0" rtlCol="0" anchor="t"/>
           <a:lstStyle/>
           <a:p>
-            <a:pPr indent="0" marL="0">
+            <a:pPr marL="0" indent="0">
               <a:buNone/>
             </a:pPr>
             <a:r>
@@ -8568,7 +8477,7 @@
       </p:sp>
       <p:sp>
         <p:nvSpPr>
-          <p:cNvPr id="7" name="Metric Error rate"/>
+          <p:cNvPr id="3" name="Metric Error rate"/>
           <p:cNvSpPr/>
           <p:nvPr/>
         </p:nvSpPr>
@@ -8614,7 +8523,7 @@
           <a:bodyPr wrap="square" lIns="0" tIns="0" rIns="0" bIns="0" rtlCol="0" anchor="t"/>
           <a:lstStyle/>
           <a:p>
-            <a:pPr indent="0" marL="0">
+            <a:pPr marL="0" indent="0">
               <a:buNone/>
             </a:pPr>
             <a:r>
@@ -8653,7 +8562,7 @@
           <a:bodyPr wrap="square" lIns="0" tIns="0" rIns="0" bIns="0" rtlCol="0" anchor="t"/>
           <a:lstStyle/>
           <a:p>
-            <a:pPr indent="0" marL="0">
+            <a:pPr marL="0" indent="0">
               <a:buNone/>
             </a:pPr>
             <a:r>
@@ -8719,7 +8628,7 @@
           <a:bodyPr wrap="square" lIns="0" tIns="0" rIns="0" bIns="0" rtlCol="0" anchor="t"/>
           <a:lstStyle/>
           <a:p>
-            <a:pPr indent="0" marL="0">
+            <a:pPr marL="0" indent="0">
               <a:buNone/>
             </a:pPr>
             <a:r>
@@ -8758,7 +8667,7 @@
           <a:bodyPr wrap="square" lIns="0" tIns="0" rIns="0" bIns="0" rtlCol="0" anchor="t"/>
           <a:lstStyle/>
           <a:p>
-            <a:pPr indent="0" marL="0">
+            <a:pPr marL="0" indent="0">
               <a:buNone/>
             </a:pPr>
             <a:r>
@@ -8824,7 +8733,7 @@
           <a:bodyPr wrap="square" lIns="0" tIns="0" rIns="0" bIns="0" rtlCol="0" anchor="t"/>
           <a:lstStyle/>
           <a:p>
-            <a:pPr indent="0" marL="0">
+            <a:pPr marL="0" indent="0">
               <a:buNone/>
             </a:pPr>
             <a:r>
@@ -8863,7 +8772,7 @@
           <a:bodyPr wrap="square" lIns="0" tIns="0" rIns="0" bIns="0" rtlCol="0" anchor="t"/>
           <a:lstStyle/>
           <a:p>
-            <a:pPr indent="0" marL="0">
+            <a:pPr marL="0" indent="0">
               <a:buNone/>
             </a:pPr>
             <a:r>
@@ -8901,7 +8810,7 @@
           </a:prstGeom>
           <a:extLst>
             <a:ext uri="{C572A759-6A51-4108-AA02-DFA0A04FC94B}">
-              <ma14:wrappingTextBoxFlag xmlns:ma14="http://schemas.microsoft.com/office/mac/drawingml/2011/main" val="0"/>
+              <ma14:wrappingTextBoxFlag xmlns:ma14="http://schemas.microsoft.com/office/mac/drawingml/2011/main" xmlns="" val="0"/>
             </a:ext>
           </a:extLst>
         </p:spPr>
@@ -8922,7 +8831,7 @@
           <a:p>
             <a:pPr algn="l"/>
             <a:fld id="{F7021451-1387-4CA6-816F-3879F97B5CBC}" type="slidenum">
-              <a:rPr b="0" lang="en-US"/>
+              <a:rPr lang="en-US" b="0"/>
               <a:t>6</a:t>
             </a:fld>
             <a:endParaRPr lang="en-US"/>
@@ -8957,9 +8866,11 @@
       <p:sp>
         <p:nvSpPr>
           <p:cNvPr id="2" name="Text 0"/>
-          <p:cNvSpPr/>
+          <p:cNvSpPr>
+            <a:spLocks noGrp="1"/>
+          </p:cNvSpPr>
           <p:nvPr>
-            <p:ph idx="100" type="title" hasCustomPrompt="1"/>
+            <p:ph type="title" idx="100" hasCustomPrompt="1"/>
           </p:nvPr>
         </p:nvSpPr>
         <p:spPr>
@@ -8977,7 +8888,7 @@
           <a:bodyPr wrap="square" lIns="0" tIns="0" rIns="0" bIns="0" rtlCol="0" anchor="ctr"/>
           <a:lstStyle/>
           <a:p>
-            <a:pPr algn="l" indent="0" marL="0">
+            <a:pPr marL="0" indent="0" algn="l">
               <a:buNone/>
             </a:pPr>
             <a:r>
@@ -9043,7 +8954,7 @@
           <a:bodyPr wrap="square" lIns="0" tIns="0" rIns="0" bIns="0" rtlCol="0" anchor="ctr"/>
           <a:lstStyle/>
           <a:p>
-            <a:pPr algn="ctr" indent="0" marL="0">
+            <a:pPr marL="0" indent="0" algn="ctr">
               <a:buNone/>
             </a:pPr>
             <a:r>
@@ -9070,23 +8981,41 @@
           <p:nvPr>
             <p:extLst>
               <p:ext uri="{D42A27DB-BD31-4B8C-83A1-F6EECF244321}">
-                <p14:modId xmlns:p14="http://schemas.microsoft.com/office/powerpoint/2010/main" val="1579011935"/>
+                <p14:modId xmlns:p14="http://schemas.microsoft.com/office/powerpoint/2010/main" val="1253127096"/>
               </p:ext>
             </p:extLst>
           </p:nvPr>
         </p:nvGraphicFramePr>
         <p:xfrm>
           <a:off x="457200" y="1600200"/>
-          <a:ext cx="3840480" cy="914400"/>
+          <a:ext cx="3840480" cy="2743200"/>
         </p:xfrm>
         <a:graphic>
           <a:graphicData uri="http://schemas.openxmlformats.org/drawingml/2006/table">
             <a:tbl>
               <a:tblPr/>
               <a:tblGrid>
-                <a:gridCol w="1737360"/>
-                <a:gridCol w="1005840"/>
-                <a:gridCol w="1097280"/>
+                <a:gridCol w="1737360">
+                  <a:extLst>
+                    <a:ext uri="{9D8B030D-6E8A-4147-A177-3AD203B41FA5}">
+                      <a16:colId xmlns:a16="http://schemas.microsoft.com/office/drawing/2014/main" val="20000"/>
+                    </a:ext>
+                  </a:extLst>
+                </a:gridCol>
+                <a:gridCol w="1005840">
+                  <a:extLst>
+                    <a:ext uri="{9D8B030D-6E8A-4147-A177-3AD203B41FA5}">
+                      <a16:colId xmlns:a16="http://schemas.microsoft.com/office/drawing/2014/main" val="20001"/>
+                    </a:ext>
+                  </a:extLst>
+                </a:gridCol>
+                <a:gridCol w="1097280">
+                  <a:extLst>
+                    <a:ext uri="{9D8B030D-6E8A-4147-A177-3AD203B41FA5}">
+                      <a16:colId xmlns:a16="http://schemas.microsoft.com/office/drawing/2014/main" val="20002"/>
+                    </a:ext>
+                  </a:extLst>
+                </a:gridCol>
               </a:tblGrid>
               <a:tr h="457200">
                 <a:tc>
@@ -9094,7 +9023,7 @@
                     <a:bodyPr/>
                     <a:lstStyle/>
                     <a:p>
-                      <a:pPr algn="l" indent="0" marL="0">
+                      <a:pPr marL="0" indent="0" algn="l">
                         <a:buNone/>
                       </a:pPr>
                       <a:r>
@@ -9115,7 +9044,7 @@
                       </a:endParaRPr>
                     </a:p>
                   </a:txBody>
-                  <a:tcPr marL="91440" marR="91440" marT="0" marB="0" anchor="ctr">
+                  <a:tcPr marT="0" marB="0" anchor="ctr">
                     <a:lnL w="9525" cap="flat" cmpd="sng" algn="ctr">
                       <a:solidFill>
                         <a:srgbClr val="D5DCE4"/>
@@ -9162,7 +9091,7 @@
                     <a:bodyPr/>
                     <a:lstStyle/>
                     <a:p>
-                      <a:pPr algn="l" indent="0" marL="0">
+                      <a:pPr marL="0" indent="0" algn="l">
                         <a:buNone/>
                       </a:pPr>
                       <a:r>
@@ -9183,7 +9112,7 @@
                       </a:endParaRPr>
                     </a:p>
                   </a:txBody>
-                  <a:tcPr marL="91440" marR="91440" marT="0" marB="0" anchor="ctr">
+                  <a:tcPr marT="0" marB="0" anchor="ctr">
                     <a:lnL w="9525" cap="flat" cmpd="sng" algn="ctr">
                       <a:solidFill>
                         <a:srgbClr val="D5DCE4"/>
@@ -9230,7 +9159,7 @@
                     <a:bodyPr/>
                     <a:lstStyle/>
                     <a:p>
-                      <a:pPr algn="l" indent="0" marL="0">
+                      <a:pPr marL="0" indent="0" algn="l">
                         <a:buNone/>
                       </a:pPr>
                       <a:r>
@@ -9251,7 +9180,7 @@
                       </a:endParaRPr>
                     </a:p>
                   </a:txBody>
-                  <a:tcPr marL="91440" marR="91440" marT="0" marB="0" anchor="ctr">
+                  <a:tcPr marT="0" marB="0" anchor="ctr">
                     <a:lnL w="9525" cap="flat" cmpd="sng" algn="ctr">
                       <a:solidFill>
                         <a:srgbClr val="D5DCE4"/>
@@ -9293,6 +9222,11 @@
                     </a:solidFill>
                   </a:tcPr>
                 </a:tc>
+                <a:extLst>
+                  <a:ext uri="{0D108BD9-81ED-4DB2-BD59-A6C34878D82A}">
+                    <a16:rowId xmlns:a16="http://schemas.microsoft.com/office/drawing/2014/main" val="10000"/>
+                  </a:ext>
+                </a:extLst>
               </a:tr>
               <a:tr h="457200">
                 <a:tc>
@@ -9300,7 +9234,7 @@
                     <a:bodyPr/>
                     <a:lstStyle/>
                     <a:p>
-                      <a:pPr indent="0" marL="0">
+                      <a:pPr marL="0" indent="0">
                         <a:buNone/>
                       </a:pPr>
                       <a:r>
@@ -9321,7 +9255,7 @@
                       </a:endParaRPr>
                     </a:p>
                   </a:txBody>
-                  <a:tcPr marL="91440" marR="91440" marT="0" marB="0" anchor="ctr">
+                  <a:tcPr marT="0" marB="0" anchor="ctr">
                     <a:lnL w="9525" cap="flat" cmpd="sng" algn="ctr">
                       <a:solidFill>
                         <a:srgbClr val="D5DCE4"/>
@@ -9365,7 +9299,7 @@
                     <a:bodyPr/>
                     <a:lstStyle/>
                     <a:p>
-                      <a:pPr algn="ctr" indent="0" marL="0">
+                      <a:pPr marL="0" indent="0" algn="ctr">
                         <a:buNone/>
                       </a:pPr>
                       <a:r>
@@ -9377,7 +9311,7 @@
                           <a:ea typeface="Calibri" pitchFamily="34" charset="-122"/>
                           <a:cs typeface="Calibri" pitchFamily="34" charset="-120"/>
                         </a:rPr>
-                        <a:t>—</a:t>
+                        <a:t>100%</a:t>
                       </a:r>
                       <a:endParaRPr lang="en-US" sz="1300" dirty="0">
                         <a:latin typeface="Calibri" charset="0"/>
@@ -9386,7 +9320,7 @@
                       </a:endParaRPr>
                     </a:p>
                   </a:txBody>
-                  <a:tcPr marL="91440" marR="91440" marT="0" marB="0" anchor="ctr">
+                  <a:tcPr marT="0" marB="0" anchor="ctr">
                     <a:lnL w="9525" cap="flat" cmpd="sng" algn="ctr">
                       <a:solidFill>
                         <a:srgbClr val="D5DCE4"/>
@@ -9430,7 +9364,7 @@
                     <a:bodyPr/>
                     <a:lstStyle/>
                     <a:p>
-                      <a:pPr algn="ctr" indent="0" marL="0">
+                      <a:pPr marL="0" indent="0" algn="ctr">
                         <a:buNone/>
                       </a:pPr>
                       <a:r>
@@ -9442,7 +9376,7 @@
                           <a:ea typeface="Calibri" pitchFamily="34" charset="-122"/>
                           <a:cs typeface="Calibri" pitchFamily="34" charset="-120"/>
                         </a:rPr>
-                        <a:t>—</a:t>
+                        <a:t>100%</a:t>
                       </a:r>
                       <a:endParaRPr lang="en-US" sz="1300" dirty="0">
                         <a:latin typeface="Calibri" charset="0"/>
@@ -9451,7 +9385,7 @@
                       </a:endParaRPr>
                     </a:p>
                   </a:txBody>
-                  <a:tcPr marL="91440" marR="91440" marT="0" marB="0" anchor="ctr">
+                  <a:tcPr marT="0" marB="0" anchor="ctr">
                     <a:lnL w="9525" cap="flat" cmpd="sng" algn="ctr">
                       <a:solidFill>
                         <a:srgbClr val="D5DCE4"/>
@@ -9490,6 +9424,11 @@
                     </a:lnB>
                   </a:tcPr>
                 </a:tc>
+                <a:extLst>
+                  <a:ext uri="{0D108BD9-81ED-4DB2-BD59-A6C34878D82A}">
+                    <a16:rowId xmlns:a16="http://schemas.microsoft.com/office/drawing/2014/main" val="10001"/>
+                  </a:ext>
+                </a:extLst>
               </a:tr>
               <a:tr h="457200">
                 <a:tc>
@@ -9497,7 +9436,7 @@
                     <a:bodyPr/>
                     <a:lstStyle/>
                     <a:p>
-                      <a:pPr indent="0" marL="0">
+                      <a:pPr marL="0" indent="0">
                         <a:buNone/>
                       </a:pPr>
                       <a:r>
@@ -9518,7 +9457,7 @@
                       </a:endParaRPr>
                     </a:p>
                   </a:txBody>
-                  <a:tcPr marL="91440" marR="91440" marT="0" marB="0" anchor="ctr">
+                  <a:tcPr marT="0" marB="0" anchor="ctr">
                     <a:lnL w="9525" cap="flat" cmpd="sng" algn="ctr">
                       <a:solidFill>
                         <a:srgbClr val="D5DCE4"/>
@@ -9562,7 +9501,7 @@
                     <a:bodyPr/>
                     <a:lstStyle/>
                     <a:p>
-                      <a:pPr algn="ctr" indent="0" marL="0">
+                      <a:pPr marL="0" indent="0" algn="ctr">
                         <a:buNone/>
                       </a:pPr>
                       <a:r>
@@ -9574,7 +9513,7 @@
                           <a:ea typeface="Calibri" pitchFamily="34" charset="-122"/>
                           <a:cs typeface="Calibri" pitchFamily="34" charset="-120"/>
                         </a:rPr>
-                        <a:t>—</a:t>
+                        <a:t>0%</a:t>
                       </a:r>
                       <a:endParaRPr lang="en-US" sz="1300" dirty="0">
                         <a:latin typeface="Calibri" charset="0"/>
@@ -9583,7 +9522,7 @@
                       </a:endParaRPr>
                     </a:p>
                   </a:txBody>
-                  <a:tcPr marL="91440" marR="91440" marT="0" marB="0" anchor="ctr">
+                  <a:tcPr marT="0" marB="0" anchor="ctr">
                     <a:lnL w="9525" cap="flat" cmpd="sng" algn="ctr">
                       <a:solidFill>
                         <a:srgbClr val="D5DCE4"/>
@@ -9627,7 +9566,7 @@
                     <a:bodyPr/>
                     <a:lstStyle/>
                     <a:p>
-                      <a:pPr algn="ctr" indent="0" marL="0">
+                      <a:pPr marL="0" indent="0" algn="ctr">
                         <a:buNone/>
                       </a:pPr>
                       <a:r>
@@ -9639,7 +9578,7 @@
                           <a:ea typeface="Calibri" pitchFamily="34" charset="-122"/>
                           <a:cs typeface="Calibri" pitchFamily="34" charset="-120"/>
                         </a:rPr>
-                        <a:t>—</a:t>
+                        <a:t>0%</a:t>
                       </a:r>
                       <a:endParaRPr lang="en-US" sz="1300" dirty="0">
                         <a:latin typeface="Calibri" charset="0"/>
@@ -9648,7 +9587,7 @@
                       </a:endParaRPr>
                     </a:p>
                   </a:txBody>
-                  <a:tcPr marL="91440" marR="91440" marT="0" marB="0" anchor="ctr">
+                  <a:tcPr marT="0" marB="0" anchor="ctr">
                     <a:lnL w="9525" cap="flat" cmpd="sng" algn="ctr">
                       <a:solidFill>
                         <a:srgbClr val="D5DCE4"/>
@@ -9687,6 +9626,11 @@
                     </a:lnB>
                   </a:tcPr>
                 </a:tc>
+                <a:extLst>
+                  <a:ext uri="{0D108BD9-81ED-4DB2-BD59-A6C34878D82A}">
+                    <a16:rowId xmlns:a16="http://schemas.microsoft.com/office/drawing/2014/main" val="10002"/>
+                  </a:ext>
+                </a:extLst>
               </a:tr>
               <a:tr h="457200">
                 <a:tc>
@@ -9694,7 +9638,7 @@
                     <a:bodyPr/>
                     <a:lstStyle/>
                     <a:p>
-                      <a:pPr indent="0" marL="0">
+                      <a:pPr marL="0" indent="0">
                         <a:buNone/>
                       </a:pPr>
                       <a:r>
@@ -9715,7 +9659,7 @@
                       </a:endParaRPr>
                     </a:p>
                   </a:txBody>
-                  <a:tcPr marL="91440" marR="91440" marT="0" marB="0" anchor="ctr">
+                  <a:tcPr marT="0" marB="0" anchor="ctr">
                     <a:lnL w="9525" cap="flat" cmpd="sng" algn="ctr">
                       <a:solidFill>
                         <a:srgbClr val="D5DCE4"/>
@@ -9759,7 +9703,7 @@
                     <a:bodyPr/>
                     <a:lstStyle/>
                     <a:p>
-                      <a:pPr algn="ctr" indent="0" marL="0">
+                      <a:pPr marL="0" indent="0" algn="ctr">
                         <a:buNone/>
                       </a:pPr>
                       <a:r>
@@ -9771,7 +9715,7 @@
                           <a:ea typeface="Calibri" pitchFamily="34" charset="-122"/>
                           <a:cs typeface="Calibri" pitchFamily="34" charset="-120"/>
                         </a:rPr>
-                        <a:t>—</a:t>
+                        <a:t>3.32</a:t>
                       </a:r>
                       <a:endParaRPr lang="en-US" sz="1300" dirty="0">
                         <a:latin typeface="Calibri" charset="0"/>
@@ -9780,7 +9724,7 @@
                       </a:endParaRPr>
                     </a:p>
                   </a:txBody>
-                  <a:tcPr marL="91440" marR="91440" marT="0" marB="0" anchor="ctr">
+                  <a:tcPr marT="0" marB="0" anchor="ctr">
                     <a:lnL w="9525" cap="flat" cmpd="sng" algn="ctr">
                       <a:solidFill>
                         <a:srgbClr val="D5DCE4"/>
@@ -9824,7 +9768,7 @@
                     <a:bodyPr/>
                     <a:lstStyle/>
                     <a:p>
-                      <a:pPr algn="ctr" indent="0" marL="0">
+                      <a:pPr marL="0" indent="0" algn="ctr">
                         <a:buNone/>
                       </a:pPr>
                       <a:r>
@@ -9836,7 +9780,7 @@
                           <a:ea typeface="Calibri" pitchFamily="34" charset="-122"/>
                           <a:cs typeface="Calibri" pitchFamily="34" charset="-120"/>
                         </a:rPr>
-                        <a:t>—</a:t>
+                        <a:t>7.08</a:t>
                       </a:r>
                       <a:endParaRPr lang="en-US" sz="1300" dirty="0">
                         <a:latin typeface="Calibri" charset="0"/>
@@ -9845,7 +9789,7 @@
                       </a:endParaRPr>
                     </a:p>
                   </a:txBody>
-                  <a:tcPr marL="91440" marR="91440" marT="0" marB="0" anchor="ctr">
+                  <a:tcPr marT="0" marB="0" anchor="ctr">
                     <a:lnL w="9525" cap="flat" cmpd="sng" algn="ctr">
                       <a:solidFill>
                         <a:srgbClr val="D5DCE4"/>
@@ -9884,6 +9828,11 @@
                     </a:lnB>
                   </a:tcPr>
                 </a:tc>
+                <a:extLst>
+                  <a:ext uri="{0D108BD9-81ED-4DB2-BD59-A6C34878D82A}">
+                    <a16:rowId xmlns:a16="http://schemas.microsoft.com/office/drawing/2014/main" val="10003"/>
+                  </a:ext>
+                </a:extLst>
               </a:tr>
               <a:tr h="457200">
                 <a:tc>
@@ -9891,7 +9840,7 @@
                     <a:bodyPr/>
                     <a:lstStyle/>
                     <a:p>
-                      <a:pPr indent="0" marL="0">
+                      <a:pPr marL="0" indent="0">
                         <a:buNone/>
                       </a:pPr>
                       <a:r>
@@ -9912,7 +9861,7 @@
                       </a:endParaRPr>
                     </a:p>
                   </a:txBody>
-                  <a:tcPr marL="91440" marR="91440" marT="0" marB="0" anchor="ctr">
+                  <a:tcPr marT="0" marB="0" anchor="ctr">
                     <a:lnL w="9525" cap="flat" cmpd="sng" algn="ctr">
                       <a:solidFill>
                         <a:srgbClr val="D5DCE4"/>
@@ -9956,7 +9905,7 @@
                     <a:bodyPr/>
                     <a:lstStyle/>
                     <a:p>
-                      <a:pPr algn="ctr" indent="0" marL="0">
+                      <a:pPr marL="0" indent="0" algn="ctr">
                         <a:buNone/>
                       </a:pPr>
                       <a:r>
@@ -9968,7 +9917,7 @@
                           <a:ea typeface="Calibri" pitchFamily="34" charset="-122"/>
                           <a:cs typeface="Calibri" pitchFamily="34" charset="-120"/>
                         </a:rPr>
-                        <a:t>—</a:t>
+                        <a:t>42.33</a:t>
                       </a:r>
                       <a:endParaRPr lang="en-US" sz="1300" dirty="0">
                         <a:latin typeface="Calibri" charset="0"/>
@@ -9977,7 +9926,7 @@
                       </a:endParaRPr>
                     </a:p>
                   </a:txBody>
-                  <a:tcPr marL="91440" marR="91440" marT="0" marB="0" anchor="ctr">
+                  <a:tcPr marT="0" marB="0" anchor="ctr">
                     <a:lnL w="9525" cap="flat" cmpd="sng" algn="ctr">
                       <a:solidFill>
                         <a:srgbClr val="D5DCE4"/>
@@ -10021,7 +9970,7 @@
                     <a:bodyPr/>
                     <a:lstStyle/>
                     <a:p>
-                      <a:pPr algn="ctr" indent="0" marL="0">
+                      <a:pPr marL="0" indent="0" algn="ctr">
                         <a:buNone/>
                       </a:pPr>
                       <a:r>
@@ -10033,7 +9982,7 @@
                           <a:ea typeface="Calibri" pitchFamily="34" charset="-122"/>
                           <a:cs typeface="Calibri" pitchFamily="34" charset="-120"/>
                         </a:rPr>
-                        <a:t>—</a:t>
+                        <a:t>62.71</a:t>
                       </a:r>
                       <a:endParaRPr lang="en-US" sz="1300" dirty="0">
                         <a:latin typeface="Calibri" charset="0"/>
@@ -10042,7 +9991,7 @@
                       </a:endParaRPr>
                     </a:p>
                   </a:txBody>
-                  <a:tcPr marL="91440" marR="91440" marT="0" marB="0" anchor="ctr">
+                  <a:tcPr marT="0" marB="0" anchor="ctr">
                     <a:lnL w="9525" cap="flat" cmpd="sng" algn="ctr">
                       <a:solidFill>
                         <a:srgbClr val="D5DCE4"/>
@@ -10081,6 +10030,11 @@
                     </a:lnB>
                   </a:tcPr>
                 </a:tc>
+                <a:extLst>
+                  <a:ext uri="{0D108BD9-81ED-4DB2-BD59-A6C34878D82A}">
+                    <a16:rowId xmlns:a16="http://schemas.microsoft.com/office/drawing/2014/main" val="10004"/>
+                  </a:ext>
+                </a:extLst>
               </a:tr>
               <a:tr h="457200">
                 <a:tc>
@@ -10088,7 +10042,7 @@
                     <a:bodyPr/>
                     <a:lstStyle/>
                     <a:p>
-                      <a:pPr indent="0" marL="0">
+                      <a:pPr marL="0" indent="0">
                         <a:buNone/>
                       </a:pPr>
                       <a:r>
@@ -10109,7 +10063,7 @@
                       </a:endParaRPr>
                     </a:p>
                   </a:txBody>
-                  <a:tcPr marL="91440" marR="91440" marT="0" marB="0" anchor="ctr">
+                  <a:tcPr marT="0" marB="0" anchor="ctr">
                     <a:lnL w="9525" cap="flat" cmpd="sng" algn="ctr">
                       <a:solidFill>
                         <a:srgbClr val="D5DCE4"/>
@@ -10153,7 +10107,7 @@
                     <a:bodyPr/>
                     <a:lstStyle/>
                     <a:p>
-                      <a:pPr algn="ctr" indent="0" marL="0">
+                      <a:pPr marL="0" indent="0" algn="ctr">
                         <a:buNone/>
                       </a:pPr>
                       <a:r>
@@ -10165,7 +10119,7 @@
                           <a:ea typeface="Calibri" pitchFamily="34" charset="-122"/>
                           <a:cs typeface="Calibri" pitchFamily="34" charset="-120"/>
                         </a:rPr>
-                        <a:t>—</a:t>
+                        <a:t>3.00</a:t>
                       </a:r>
                       <a:endParaRPr lang="en-US" sz="1300" dirty="0">
                         <a:latin typeface="Calibri" charset="0"/>
@@ -10174,7 +10128,7 @@
                       </a:endParaRPr>
                     </a:p>
                   </a:txBody>
-                  <a:tcPr marL="91440" marR="91440" marT="0" marB="0" anchor="ctr">
+                  <a:tcPr marT="0" marB="0" anchor="ctr">
                     <a:lnL w="9525" cap="flat" cmpd="sng" algn="ctr">
                       <a:solidFill>
                         <a:srgbClr val="D5DCE4"/>
@@ -10218,7 +10172,7 @@
                     <a:bodyPr/>
                     <a:lstStyle/>
                     <a:p>
-                      <a:pPr algn="ctr" indent="0" marL="0">
+                      <a:pPr marL="0" indent="0" algn="ctr">
                         <a:buNone/>
                       </a:pPr>
                       <a:r>
@@ -10230,7 +10184,7 @@
                           <a:ea typeface="Calibri" pitchFamily="34" charset="-122"/>
                           <a:cs typeface="Calibri" pitchFamily="34" charset="-120"/>
                         </a:rPr>
-                        <a:t>—</a:t>
+                        <a:t>363.14</a:t>
                       </a:r>
                       <a:endParaRPr lang="en-US" sz="1300" dirty="0">
                         <a:latin typeface="Calibri" charset="0"/>
@@ -10239,7 +10193,7 @@
                       </a:endParaRPr>
                     </a:p>
                   </a:txBody>
-                  <a:tcPr marL="91440" marR="91440" marT="0" marB="0" anchor="ctr">
+                  <a:tcPr marT="0" marB="0" anchor="ctr">
                     <a:lnL w="9525" cap="flat" cmpd="sng" algn="ctr">
                       <a:solidFill>
                         <a:srgbClr val="D5DCE4"/>
@@ -10278,6 +10232,11 @@
                     </a:lnB>
                   </a:tcPr>
                 </a:tc>
+                <a:extLst>
+                  <a:ext uri="{0D108BD9-81ED-4DB2-BD59-A6C34878D82A}">
+                    <a16:rowId xmlns:a16="http://schemas.microsoft.com/office/drawing/2014/main" val="10005"/>
+                  </a:ext>
+                </a:extLst>
               </a:tr>
             </a:tbl>
           </a:graphicData>
@@ -10285,7 +10244,7 @@
       </p:graphicFrame>
       <p:graphicFrame>
         <p:nvGraphicFramePr>
-          <p:cNvPr id="6" name="Chart 0" descr=""/>
+          <p:cNvPr id="6" name="Chart 0"/>
           <p:cNvGraphicFramePr/>
           <p:nvPr/>
         </p:nvGraphicFramePr>
@@ -10293,9 +10252,9 @@
           <a:off x="4572000" y="1554480"/>
           <a:ext cx="4114800" cy="2971800"/>
         </p:xfrm>
-        <a:graphic xmlns:a="http://schemas.openxmlformats.org/drawingml/2006/main">
+        <a:graphic>
           <a:graphicData uri="http://schemas.openxmlformats.org/drawingml/2006/chart">
-            <c:chart xmlns:c="http://schemas.openxmlformats.org/drawingml/2006/chart" r:id="rId1"/>
+            <c:chart xmlns:c="http://schemas.openxmlformats.org/drawingml/2006/chart" xmlns:r="http://schemas.openxmlformats.org/officeDocument/2006/relationships" r:id="rId3"/>
           </a:graphicData>
         </a:graphic>
       </p:graphicFrame>
@@ -10319,7 +10278,7 @@
           </a:prstGeom>
           <a:extLst>
             <a:ext uri="{C572A759-6A51-4108-AA02-DFA0A04FC94B}">
-              <ma14:wrappingTextBoxFlag xmlns:ma14="http://schemas.microsoft.com/office/mac/drawingml/2011/main" val="0"/>
+              <ma14:wrappingTextBoxFlag xmlns:ma14="http://schemas.microsoft.com/office/mac/drawingml/2011/main" xmlns="" val="0"/>
             </a:ext>
           </a:extLst>
         </p:spPr>
@@ -10340,7 +10299,7 @@
           <a:p>
             <a:pPr algn="l"/>
             <a:fld id="{F7021451-1387-4CA6-816F-3879F97B5CBC}" type="slidenum">
-              <a:rPr b="0" lang="en-US"/>
+              <a:rPr lang="en-US" b="0"/>
               <a:t>7</a:t>
             </a:fld>
             <a:endParaRPr lang="en-US"/>
@@ -10375,9 +10334,11 @@
       <p:sp>
         <p:nvSpPr>
           <p:cNvPr id="2" name="Text 0"/>
-          <p:cNvSpPr/>
+          <p:cNvSpPr>
+            <a:spLocks noGrp="1"/>
+          </p:cNvSpPr>
           <p:nvPr>
-            <p:ph idx="100" type="title" hasCustomPrompt="1"/>
+            <p:ph type="title" idx="100" hasCustomPrompt="1"/>
           </p:nvPr>
         </p:nvSpPr>
         <p:spPr>
@@ -10395,7 +10356,7 @@
           <a:bodyPr wrap="square" lIns="0" tIns="0" rIns="0" bIns="0" rtlCol="0" anchor="ctr"/>
           <a:lstStyle/>
           <a:p>
-            <a:pPr algn="l" indent="0" marL="0">
+            <a:pPr marL="0" indent="0" algn="l">
               <a:buNone/>
             </a:pPr>
             <a:r>
@@ -10461,7 +10422,7 @@
           <a:bodyPr wrap="square" lIns="0" tIns="0" rIns="0" bIns="0" rtlCol="0" anchor="t"/>
           <a:lstStyle/>
           <a:p>
-            <a:pPr indent="0" marL="0">
+            <a:pPr marL="0" indent="0">
               <a:buNone/>
             </a:pPr>
             <a:r>
@@ -10633,7 +10594,7 @@
           <a:bodyPr wrap="square" lIns="0" tIns="0" rIns="0" bIns="0" rtlCol="0" anchor="t"/>
           <a:lstStyle/>
           <a:p>
-            <a:pPr indent="0" marL="0">
+            <a:pPr marL="0" indent="0">
               <a:buNone/>
             </a:pPr>
             <a:r>
@@ -10777,7 +10738,7 @@
           </a:prstGeom>
           <a:extLst>
             <a:ext uri="{C572A759-6A51-4108-AA02-DFA0A04FC94B}">
-              <ma14:wrappingTextBoxFlag xmlns:ma14="http://schemas.microsoft.com/office/mac/drawingml/2011/main" val="0"/>
+              <ma14:wrappingTextBoxFlag xmlns:ma14="http://schemas.microsoft.com/office/mac/drawingml/2011/main" xmlns="" val="0"/>
             </a:ext>
           </a:extLst>
         </p:spPr>
@@ -10798,7 +10759,7 @@
           <a:p>
             <a:pPr algn="l"/>
             <a:fld id="{F7021451-1387-4CA6-816F-3879F97B5CBC}" type="slidenum">
-              <a:rPr b="0" lang="en-US"/>
+              <a:rPr lang="en-US" b="0"/>
               <a:t>8</a:t>
             </a:fld>
             <a:endParaRPr lang="en-US"/>
@@ -10833,9 +10794,11 @@
       <p:sp>
         <p:nvSpPr>
           <p:cNvPr id="2" name="Text 0"/>
-          <p:cNvSpPr/>
+          <p:cNvSpPr>
+            <a:spLocks noGrp="1"/>
+          </p:cNvSpPr>
           <p:nvPr>
-            <p:ph idx="100" type="title" hasCustomPrompt="1"/>
+            <p:ph type="title" idx="100" hasCustomPrompt="1"/>
           </p:nvPr>
         </p:nvSpPr>
         <p:spPr>
@@ -10853,7 +10816,7 @@
           <a:bodyPr wrap="square" lIns="0" tIns="0" rIns="0" bIns="0" rtlCol="0" anchor="ctr"/>
           <a:lstStyle/>
           <a:p>
-            <a:pPr algn="l" indent="0" marL="0">
+            <a:pPr marL="0" indent="0" algn="l">
               <a:buNone/>
             </a:pPr>
             <a:r>
@@ -10919,7 +10882,7 @@
           <a:bodyPr wrap="square" lIns="0" tIns="0" rIns="0" bIns="0" rtlCol="0" anchor="t"/>
           <a:lstStyle/>
           <a:p>
-            <a:pPr indent="0" marL="0">
+            <a:pPr marL="0" indent="0">
               <a:buNone/>
             </a:pPr>
             <a:r>
@@ -10958,7 +10921,7 @@
           <a:bodyPr wrap="square" lIns="0" tIns="0" rIns="0" bIns="0" rtlCol="0" anchor="t"/>
           <a:lstStyle/>
           <a:p>
-            <a:pPr indent="0" marL="0">
+            <a:pPr marL="0" indent="0">
               <a:buNone/>
             </a:pPr>
             <a:r>
@@ -10997,7 +10960,7 @@
           <a:bodyPr wrap="square" lIns="0" tIns="0" rIns="0" bIns="0" rtlCol="0" anchor="t"/>
           <a:lstStyle/>
           <a:p>
-            <a:pPr indent="0" marL="0">
+            <a:pPr marL="0" indent="0">
               <a:buNone/>
             </a:pPr>
             <a:r>
@@ -11063,7 +11026,7 @@
           <a:bodyPr wrap="square" lIns="0" tIns="0" rIns="0" bIns="0" rtlCol="0" anchor="t"/>
           <a:lstStyle/>
           <a:p>
-            <a:pPr indent="0" marL="0">
+            <a:pPr marL="0" indent="0">
               <a:buNone/>
             </a:pPr>
             <a:r>
@@ -11102,7 +11065,7 @@
           <a:bodyPr wrap="square" lIns="0" tIns="0" rIns="0" bIns="0" rtlCol="0" anchor="t"/>
           <a:lstStyle/>
           <a:p>
-            <a:pPr indent="0" marL="0">
+            <a:pPr marL="0" indent="0">
               <a:buNone/>
             </a:pPr>
             <a:r>
@@ -11141,7 +11104,7 @@
           <a:bodyPr wrap="square" lIns="0" tIns="0" rIns="0" bIns="0" rtlCol="0" anchor="t"/>
           <a:lstStyle/>
           <a:p>
-            <a:pPr indent="0" marL="0">
+            <a:pPr marL="0" indent="0">
               <a:buNone/>
             </a:pPr>
             <a:r>
@@ -11207,7 +11170,7 @@
           <a:bodyPr wrap="square" lIns="0" tIns="0" rIns="0" bIns="0" rtlCol="0" anchor="t"/>
           <a:lstStyle/>
           <a:p>
-            <a:pPr indent="0" marL="0">
+            <a:pPr marL="0" indent="0">
               <a:buNone/>
             </a:pPr>
             <a:r>
@@ -11246,7 +11209,7 @@
           <a:bodyPr wrap="square" lIns="0" tIns="0" rIns="0" bIns="0" rtlCol="0" anchor="t"/>
           <a:lstStyle/>
           <a:p>
-            <a:pPr indent="0" marL="0">
+            <a:pPr marL="0" indent="0">
               <a:buNone/>
             </a:pPr>
             <a:r>
@@ -11285,7 +11248,7 @@
           <a:bodyPr wrap="square" lIns="0" tIns="0" rIns="0" bIns="0" rtlCol="0" anchor="t"/>
           <a:lstStyle/>
           <a:p>
-            <a:pPr indent="0" marL="0">
+            <a:pPr marL="0" indent="0">
               <a:buNone/>
             </a:pPr>
             <a:r>
@@ -11323,7 +11286,7 @@
           </a:prstGeom>
           <a:extLst>
             <a:ext uri="{C572A759-6A51-4108-AA02-DFA0A04FC94B}">
-              <ma14:wrappingTextBoxFlag xmlns:ma14="http://schemas.microsoft.com/office/mac/drawingml/2011/main" val="0"/>
+              <ma14:wrappingTextBoxFlag xmlns:ma14="http://schemas.microsoft.com/office/mac/drawingml/2011/main" xmlns="" val="0"/>
             </a:ext>
           </a:extLst>
         </p:spPr>
@@ -11344,7 +11307,7 @@
           <a:p>
             <a:pPr algn="l"/>
             <a:fld id="{F7021451-1387-4CA6-816F-3879F97B5CBC}" type="slidenum">
-              <a:rPr b="0" lang="en-US"/>
+              <a:rPr lang="en-US" b="0"/>
               <a:t>9</a:t>
             </a:fld>
             <a:endParaRPr lang="en-US"/>
@@ -11652,4 +11615,299 @@
     </a:ext>
   </a:extLst>
 </a:theme>
+</file>
+
+<file path=ppt/theme/theme2.xml><?xml version="1.0" encoding="utf-8"?>
+<a:theme xmlns:a="http://schemas.openxmlformats.org/drawingml/2006/main" name="Office Theme">
+  <a:themeElements>
+    <a:clrScheme name="Office">
+      <a:dk1>
+        <a:sysClr val="windowText" lastClr="000000"/>
+      </a:dk1>
+      <a:lt1>
+        <a:sysClr val="window" lastClr="FFFFFF"/>
+      </a:lt1>
+      <a:dk2>
+        <a:srgbClr val="44546A"/>
+      </a:dk2>
+      <a:lt2>
+        <a:srgbClr val="E7E6E6"/>
+      </a:lt2>
+      <a:accent1>
+        <a:srgbClr val="4472C4"/>
+      </a:accent1>
+      <a:accent2>
+        <a:srgbClr val="ED7D31"/>
+      </a:accent2>
+      <a:accent3>
+        <a:srgbClr val="A5A5A5"/>
+      </a:accent3>
+      <a:accent4>
+        <a:srgbClr val="FFC000"/>
+      </a:accent4>
+      <a:accent5>
+        <a:srgbClr val="5B9BD5"/>
+      </a:accent5>
+      <a:accent6>
+        <a:srgbClr val="70AD47"/>
+      </a:accent6>
+      <a:hlink>
+        <a:srgbClr val="0563C1"/>
+      </a:hlink>
+      <a:folHlink>
+        <a:srgbClr val="954F72"/>
+      </a:folHlink>
+    </a:clrScheme>
+    <a:fontScheme name="Office">
+      <a:majorFont>
+        <a:latin typeface="Calibri Light" panose="020F0302020204030204"/>
+        <a:ea typeface=""/>
+        <a:cs typeface=""/>
+        <a:font script="Jpan" typeface="游ゴシック Light"/>
+        <a:font script="Hang" typeface="맑은 고딕"/>
+        <a:font script="Hans" typeface="等线 Light"/>
+        <a:font script="Hant" typeface="新細明體"/>
+        <a:font script="Arab" typeface="Times New Roman"/>
+        <a:font script="Hebr" typeface="Times New Roman"/>
+        <a:font script="Thai" typeface="Angsana New"/>
+        <a:font script="Ethi" typeface="Nyala"/>
+        <a:font script="Beng" typeface="Vrinda"/>
+        <a:font script="Gujr" typeface="Shruti"/>
+        <a:font script="Khmr" typeface="MoolBoran"/>
+        <a:font script="Knda" typeface="Tunga"/>
+        <a:font script="Guru" typeface="Raavi"/>
+        <a:font script="Cans" typeface="Euphemia"/>
+        <a:font script="Cher" typeface="Plantagenet Cherokee"/>
+        <a:font script="Yiii" typeface="Microsoft Yi Baiti"/>
+        <a:font script="Tibt" typeface="Microsoft Himalaya"/>
+        <a:font script="Thaa" typeface="MV Boli"/>
+        <a:font script="Deva" typeface="Mangal"/>
+        <a:font script="Telu" typeface="Gautami"/>
+        <a:font script="Taml" typeface="Latha"/>
+        <a:font script="Syrc" typeface="Estrangelo Edessa"/>
+        <a:font script="Orya" typeface="Kalinga"/>
+        <a:font script="Mlym" typeface="Kartika"/>
+        <a:font script="Laoo" typeface="DokChampa"/>
+        <a:font script="Sinh" typeface="Iskoola Pota"/>
+        <a:font script="Mong" typeface="Mongolian Baiti"/>
+        <a:font script="Viet" typeface="Times New Roman"/>
+        <a:font script="Uigh" typeface="Microsoft Uighur"/>
+        <a:font script="Geor" typeface="Sylfaen"/>
+        <a:font script="Armn" typeface="Arial"/>
+        <a:font script="Bugi" typeface="Leelawadee UI"/>
+        <a:font script="Bopo" typeface="Microsoft JhengHei"/>
+        <a:font script="Java" typeface="Javanese Text"/>
+        <a:font script="Lisu" typeface="Segoe UI"/>
+        <a:font script="Mymr" typeface="Myanmar Text"/>
+        <a:font script="Nkoo" typeface="Ebrima"/>
+        <a:font script="Olck" typeface="Nirmala UI"/>
+        <a:font script="Osma" typeface="Ebrima"/>
+        <a:font script="Phag" typeface="Phagspa"/>
+        <a:font script="Syrn" typeface="Estrangelo Edessa"/>
+        <a:font script="Syrj" typeface="Estrangelo Edessa"/>
+        <a:font script="Syre" typeface="Estrangelo Edessa"/>
+        <a:font script="Sora" typeface="Nirmala UI"/>
+        <a:font script="Tale" typeface="Microsoft Tai Le"/>
+        <a:font script="Talu" typeface="Microsoft New Tai Lue"/>
+        <a:font script="Tfng" typeface="Ebrima"/>
+      </a:majorFont>
+      <a:minorFont>
+        <a:latin typeface="Calibri" panose="020F0502020204030204"/>
+        <a:ea typeface=""/>
+        <a:cs typeface=""/>
+        <a:font script="Jpan" typeface="游ゴシック"/>
+        <a:font script="Hang" typeface="맑은 고딕"/>
+        <a:font script="Hans" typeface="等线"/>
+        <a:font script="Hant" typeface="新細明體"/>
+        <a:font script="Arab" typeface="Arial"/>
+        <a:font script="Hebr" typeface="Arial"/>
+        <a:font script="Thai" typeface="Cordia New"/>
+        <a:font script="Ethi" typeface="Nyala"/>
+        <a:font script="Beng" typeface="Vrinda"/>
+        <a:font script="Gujr" typeface="Shruti"/>
+        <a:font script="Khmr" typeface="DaunPenh"/>
+        <a:font script="Knda" typeface="Tunga"/>
+        <a:font script="Guru" typeface="Raavi"/>
+        <a:font script="Cans" typeface="Euphemia"/>
+        <a:font script="Cher" typeface="Plantagenet Cherokee"/>
+        <a:font script="Yiii" typeface="Microsoft Yi Baiti"/>
+        <a:font script="Tibt" typeface="Microsoft Himalaya"/>
+        <a:font script="Thaa" typeface="MV Boli"/>
+        <a:font script="Deva" typeface="Mangal"/>
+        <a:font script="Telu" typeface="Gautami"/>
+        <a:font script="Taml" typeface="Latha"/>
+        <a:font script="Syrc" typeface="Estrangelo Edessa"/>
+        <a:font script="Orya" typeface="Kalinga"/>
+        <a:font script="Mlym" typeface="Kartika"/>
+        <a:font script="Laoo" typeface="DokChampa"/>
+        <a:font script="Sinh" typeface="Iskoola Pota"/>
+        <a:font script="Mong" typeface="Mongolian Baiti"/>
+        <a:font script="Viet" typeface="Arial"/>
+        <a:font script="Uigh" typeface="Microsoft Uighur"/>
+        <a:font script="Geor" typeface="Sylfaen"/>
+        <a:font script="Armn" typeface="Arial"/>
+        <a:font script="Bugi" typeface="Leelawadee UI"/>
+        <a:font script="Bopo" typeface="Microsoft JhengHei"/>
+        <a:font script="Java" typeface="Javanese Text"/>
+        <a:font script="Lisu" typeface="Segoe UI"/>
+        <a:font script="Mymr" typeface="Myanmar Text"/>
+        <a:font script="Nkoo" typeface="Ebrima"/>
+        <a:font script="Olck" typeface="Nirmala UI"/>
+        <a:font script="Osma" typeface="Ebrima"/>
+        <a:font script="Phag" typeface="Phagspa"/>
+        <a:font script="Syrn" typeface="Estrangelo Edessa"/>
+        <a:font script="Syrj" typeface="Estrangelo Edessa"/>
+        <a:font script="Syre" typeface="Estrangelo Edessa"/>
+        <a:font script="Sora" typeface="Nirmala UI"/>
+        <a:font script="Tale" typeface="Microsoft Tai Le"/>
+        <a:font script="Talu" typeface="Microsoft New Tai Lue"/>
+        <a:font script="Tfng" typeface="Ebrima"/>
+      </a:minorFont>
+    </a:fontScheme>
+    <a:fmtScheme name="Office">
+      <a:fillStyleLst>
+        <a:solidFill>
+          <a:schemeClr val="phClr"/>
+        </a:solidFill>
+        <a:gradFill rotWithShape="1">
+          <a:gsLst>
+            <a:gs pos="0">
+              <a:schemeClr val="phClr">
+                <a:lumMod val="110000"/>
+                <a:satMod val="105000"/>
+                <a:tint val="67000"/>
+              </a:schemeClr>
+            </a:gs>
+            <a:gs pos="50000">
+              <a:schemeClr val="phClr">
+                <a:lumMod val="105000"/>
+                <a:satMod val="103000"/>
+                <a:tint val="73000"/>
+              </a:schemeClr>
+            </a:gs>
+            <a:gs pos="100000">
+              <a:schemeClr val="phClr">
+                <a:lumMod val="105000"/>
+                <a:satMod val="109000"/>
+                <a:tint val="81000"/>
+              </a:schemeClr>
+            </a:gs>
+          </a:gsLst>
+          <a:lin ang="5400000" scaled="0"/>
+        </a:gradFill>
+        <a:gradFill rotWithShape="1">
+          <a:gsLst>
+            <a:gs pos="0">
+              <a:schemeClr val="phClr">
+                <a:satMod val="103000"/>
+                <a:lumMod val="102000"/>
+                <a:tint val="94000"/>
+              </a:schemeClr>
+            </a:gs>
+            <a:gs pos="50000">
+              <a:schemeClr val="phClr">
+                <a:satMod val="110000"/>
+                <a:lumMod val="100000"/>
+                <a:shade val="100000"/>
+              </a:schemeClr>
+            </a:gs>
+            <a:gs pos="100000">
+              <a:schemeClr val="phClr">
+                <a:lumMod val="99000"/>
+                <a:satMod val="120000"/>
+                <a:shade val="78000"/>
+              </a:schemeClr>
+            </a:gs>
+          </a:gsLst>
+          <a:lin ang="5400000" scaled="0"/>
+        </a:gradFill>
+      </a:fillStyleLst>
+      <a:lnStyleLst>
+        <a:ln w="6350" cap="flat" cmpd="sng" algn="ctr">
+          <a:solidFill>
+            <a:schemeClr val="phClr"/>
+          </a:solidFill>
+          <a:prstDash val="solid"/>
+          <a:miter lim="800000"/>
+        </a:ln>
+        <a:ln w="12700" cap="flat" cmpd="sng" algn="ctr">
+          <a:solidFill>
+            <a:schemeClr val="phClr"/>
+          </a:solidFill>
+          <a:prstDash val="solid"/>
+          <a:miter lim="800000"/>
+        </a:ln>
+        <a:ln w="19050" cap="flat" cmpd="sng" algn="ctr">
+          <a:solidFill>
+            <a:schemeClr val="phClr"/>
+          </a:solidFill>
+          <a:prstDash val="solid"/>
+          <a:miter lim="800000"/>
+        </a:ln>
+      </a:lnStyleLst>
+      <a:effectStyleLst>
+        <a:effectStyle>
+          <a:effectLst/>
+        </a:effectStyle>
+        <a:effectStyle>
+          <a:effectLst/>
+        </a:effectStyle>
+        <a:effectStyle>
+          <a:effectLst>
+            <a:outerShdw blurRad="57150" dist="19050" dir="5400000" algn="ctr" rotWithShape="0">
+              <a:srgbClr val="000000">
+                <a:alpha val="63000"/>
+              </a:srgbClr>
+            </a:outerShdw>
+          </a:effectLst>
+        </a:effectStyle>
+      </a:effectStyleLst>
+      <a:bgFillStyleLst>
+        <a:solidFill>
+          <a:schemeClr val="phClr"/>
+        </a:solidFill>
+        <a:solidFill>
+          <a:schemeClr val="phClr">
+            <a:tint val="95000"/>
+            <a:satMod val="170000"/>
+          </a:schemeClr>
+        </a:solidFill>
+        <a:gradFill rotWithShape="1">
+          <a:gsLst>
+            <a:gs pos="0">
+              <a:schemeClr val="phClr">
+                <a:tint val="93000"/>
+                <a:satMod val="150000"/>
+                <a:shade val="98000"/>
+                <a:lumMod val="102000"/>
+              </a:schemeClr>
+            </a:gs>
+            <a:gs pos="50000">
+              <a:schemeClr val="phClr">
+                <a:tint val="98000"/>
+                <a:satMod val="130000"/>
+                <a:shade val="90000"/>
+                <a:lumMod val="103000"/>
+              </a:schemeClr>
+            </a:gs>
+            <a:gs pos="100000">
+              <a:schemeClr val="phClr">
+                <a:shade val="63000"/>
+                <a:satMod val="120000"/>
+              </a:schemeClr>
+            </a:gs>
+          </a:gsLst>
+          <a:lin ang="5400000" scaled="0"/>
+        </a:gradFill>
+      </a:bgFillStyleLst>
+    </a:fmtScheme>
+  </a:themeElements>
+  <a:objectDefaults/>
+  <a:extraClrSchemeLst/>
+  <a:extLst>
+    <a:ext uri="{05A4C25C-085E-4340-85A3-A5531E510DB2}">
+      <thm15:themeFamily xmlns:thm15="http://schemas.microsoft.com/office/thememl/2012/main" name="Office Theme" id="{62F939B6-93AF-4DB8-9C6B-D6C7DFDC589F}" vid="{4A3C46E8-61CC-4603-A589-7422A47A8E4A}"/>
+    </a:ext>
+  </a:extLst>
+</a:theme>
 </file>
</xml_diff>